<commit_message>
Updates to Product Documentation
</commit_message>
<xml_diff>
--- a/docs/2_Value_Creation/2a_Product/2a_Product_Management_Plan.pptx
+++ b/docs/2_Value_Creation/2a_Product/2a_Product_Management_Plan.pptx
@@ -5,7 +5,7 @@
     <p:sldMasterId id="2147483661" r:id="rId1"/>
   </p:sldMasterIdLst>
   <p:notesMasterIdLst>
-    <p:notesMasterId r:id="rId11"/>
+    <p:notesMasterId r:id="rId12"/>
   </p:notesMasterIdLst>
   <p:sldIdLst>
     <p:sldId id="256" r:id="rId2"/>
@@ -13,10 +13,11 @@
     <p:sldId id="418" r:id="rId4"/>
     <p:sldId id="274" r:id="rId5"/>
     <p:sldId id="400" r:id="rId6"/>
-    <p:sldId id="409" r:id="rId7"/>
-    <p:sldId id="401" r:id="rId8"/>
-    <p:sldId id="275" r:id="rId9"/>
-    <p:sldId id="273" r:id="rId10"/>
+    <p:sldId id="419" r:id="rId7"/>
+    <p:sldId id="409" r:id="rId8"/>
+    <p:sldId id="401" r:id="rId9"/>
+    <p:sldId id="275" r:id="rId10"/>
+    <p:sldId id="273" r:id="rId11"/>
   </p:sldIdLst>
   <p:sldSz cx="12192000" cy="6858000"/>
   <p:notesSz cx="6858000" cy="9144000"/>
@@ -254,18 +255,26 @@
       <p15:sldGuideLst xmlns:p15="http://schemas.microsoft.com/office/powerpoint/2012/main"/>
     </p:ext>
     <p:ext uri="GoogleSlidesCustomDataVersion2">
-      <go:slidesCustomData xmlns:mc="http://schemas.openxmlformats.org/markup-compatibility/2006" xmlns:mv="urn:schemas-microsoft-com:mac:vml" xmlns:c="http://schemas.openxmlformats.org/drawingml/2006/chart" xmlns:dgm="http://schemas.openxmlformats.org/drawingml/2006/diagram" xmlns:o="urn:schemas-microsoft-com:office:office" xmlns:v="urn:schemas-microsoft-com:vml" xmlns:pvml="urn:schemas-microsoft-com:office:powerpoint" xmlns:com="http://schemas.openxmlformats.org/drawingml/2006/compatibility" xmlns:p14="http://schemas.microsoft.com/office/powerpoint/2010/main" xmlns:p15="http://schemas.microsoft.com/office/powerpoint/2012/main" xmlns:ahyp="http://schemas.microsoft.com/office/drawing/2018/hyperlinkcolor" xmlns:go="http://customooxmlschemas.google.com/" xmlns="" r:id="rId23" roundtripDataSignature="AMtx7mhwEp+Eio5qReXqYqUwMP31HB0A8A=="/>
+      <go:slidesCustomData xmlns="" xmlns:go="http://customooxmlschemas.google.com/" xmlns:ahyp="http://schemas.microsoft.com/office/drawing/2018/hyperlinkcolor" xmlns:p15="http://schemas.microsoft.com/office/powerpoint/2012/main" xmlns:p14="http://schemas.microsoft.com/office/powerpoint/2010/main" xmlns:com="http://schemas.openxmlformats.org/drawingml/2006/compatibility" xmlns:pvml="urn:schemas-microsoft-com:office:powerpoint" xmlns:v="urn:schemas-microsoft-com:vml" xmlns:o="urn:schemas-microsoft-com:office:office" xmlns:dgm="http://schemas.openxmlformats.org/drawingml/2006/diagram" xmlns:c="http://schemas.openxmlformats.org/drawingml/2006/chart" xmlns:mv="urn:schemas-microsoft-com:mac:vml" xmlns:mc="http://schemas.openxmlformats.org/markup-compatibility/2006" r:id="rId23" roundtripDataSignature="AMtx7mhwEp+Eio5qReXqYqUwMP31HB0A8A=="/>
     </p:ext>
   </p:extLst>
 </p:presentation>
+</file>
+
+<file path=ppt/revisionInfo.xml><?xml version="1.0" encoding="utf-8"?>
+<p1510:revInfo xmlns:a="http://schemas.openxmlformats.org/drawingml/2006/main" xmlns:r="http://schemas.openxmlformats.org/officeDocument/2006/relationships" xmlns:p1510="http://schemas.microsoft.com/office/powerpoint/2015/10/main">
+  <p1510:revLst>
+    <p1510:client id="{B143809C-D10A-264C-B7BA-94778C12E332}" v="2" dt="2026-08-09T15:50:30.793"/>
+  </p1510:revLst>
+</p1510:revInfo>
 </file>
 
 <file path=ppt/changesInfos/changesInfo1.xml><?xml version="1.0" encoding="utf-8"?>
 <pc:chgInfo xmlns:a="http://schemas.openxmlformats.org/drawingml/2006/main" xmlns:r="http://schemas.openxmlformats.org/officeDocument/2006/relationships" xmlns:ac="http://schemas.microsoft.com/office/drawing/2013/main/command" xmlns:pc="http://schemas.microsoft.com/office/powerpoint/2013/main/command">
   <pc:docChgLst>
     <pc:chgData name="Rich Reba" userId="55db41ab6eb3f845" providerId="LiveId" clId="{0E19DA16-244C-5B50-BE0F-52911DD4CA7E}"/>
-    <pc:docChg chg="custSel delSld modSld">
-      <pc:chgData name="Rich Reba" userId="55db41ab6eb3f845" providerId="LiveId" clId="{0E19DA16-244C-5B50-BE0F-52911DD4CA7E}" dt="2026-08-06T20:27:05.955" v="29" actId="478"/>
+    <pc:docChg chg="custSel addSld delSld modSld">
+      <pc:chgData name="Rich Reba" userId="55db41ab6eb3f845" providerId="LiveId" clId="{0E19DA16-244C-5B50-BE0F-52911DD4CA7E}" dt="2026-08-09T15:53:38.015" v="264" actId="20577"/>
       <pc:docMkLst>
         <pc:docMk/>
       </pc:docMkLst>
@@ -290,14 +299,6 @@
           <pc:docMk/>
           <pc:sldMk cId="3601186110" sldId="273"/>
         </pc:sldMkLst>
-        <pc:spChg chg="del">
-          <ac:chgData name="Rich Reba" userId="55db41ab6eb3f845" providerId="LiveId" clId="{0E19DA16-244C-5B50-BE0F-52911DD4CA7E}" dt="2026-08-06T20:27:05.955" v="29" actId="478"/>
-          <ac:spMkLst>
-            <pc:docMk/>
-            <pc:sldMk cId="3601186110" sldId="273"/>
-            <ac:spMk id="29" creationId="{CC6B3F18-B157-6C8F-94BB-433A9E2AAE5A}"/>
-          </ac:spMkLst>
-        </pc:spChg>
       </pc:sldChg>
       <pc:sldChg chg="delSp mod">
         <pc:chgData name="Rich Reba" userId="55db41ab6eb3f845" providerId="LiveId" clId="{0E19DA16-244C-5B50-BE0F-52911DD4CA7E}" dt="2026-08-06T20:26:50.113" v="25" actId="478"/>
@@ -305,29 +306,6 @@
           <pc:docMk/>
           <pc:sldMk cId="1961190671" sldId="274"/>
         </pc:sldMkLst>
-        <pc:spChg chg="del">
-          <ac:chgData name="Rich Reba" userId="55db41ab6eb3f845" providerId="LiveId" clId="{0E19DA16-244C-5B50-BE0F-52911DD4CA7E}" dt="2026-08-06T20:26:50.113" v="25" actId="478"/>
-          <ac:spMkLst>
-            <pc:docMk/>
-            <pc:sldMk cId="1961190671" sldId="274"/>
-            <ac:spMk id="29" creationId="{CC6B3F18-B157-6C8F-94BB-433A9E2AAE5A}"/>
-          </ac:spMkLst>
-        </pc:spChg>
-      </pc:sldChg>
-      <pc:sldChg chg="delSp del mod">
-        <pc:chgData name="Rich Reba" userId="55db41ab6eb3f845" providerId="LiveId" clId="{0E19DA16-244C-5B50-BE0F-52911DD4CA7E}" dt="2026-08-06T20:19:11.548" v="16" actId="2696"/>
-        <pc:sldMkLst>
-          <pc:docMk/>
-          <pc:sldMk cId="4261285587" sldId="291"/>
-        </pc:sldMkLst>
-        <pc:spChg chg="del">
-          <ac:chgData name="Rich Reba" userId="55db41ab6eb3f845" providerId="LiveId" clId="{0E19DA16-244C-5B50-BE0F-52911DD4CA7E}" dt="2026-08-05T20:16:51.271" v="0" actId="478"/>
-          <ac:spMkLst>
-            <pc:docMk/>
-            <pc:sldMk cId="4261285587" sldId="291"/>
-            <ac:spMk id="2" creationId="{CD994921-CA85-D524-D4AC-39A78EB65DD8}"/>
-          </ac:spMkLst>
-        </pc:spChg>
       </pc:sldChg>
       <pc:sldChg chg="delSp mod">
         <pc:chgData name="Rich Reba" userId="55db41ab6eb3f845" providerId="LiveId" clId="{0E19DA16-244C-5B50-BE0F-52911DD4CA7E}" dt="2026-08-06T20:26:53.708" v="26" actId="478"/>
@@ -335,14 +313,6 @@
           <pc:docMk/>
           <pc:sldMk cId="797649862" sldId="400"/>
         </pc:sldMkLst>
-        <pc:spChg chg="del">
-          <ac:chgData name="Rich Reba" userId="55db41ab6eb3f845" providerId="LiveId" clId="{0E19DA16-244C-5B50-BE0F-52911DD4CA7E}" dt="2026-08-06T20:26:53.708" v="26" actId="478"/>
-          <ac:spMkLst>
-            <pc:docMk/>
-            <pc:sldMk cId="797649862" sldId="400"/>
-            <ac:spMk id="2" creationId="{FAEC2788-BD9D-9EED-BC5E-1AED8264C6F9}"/>
-          </ac:spMkLst>
-        </pc:spChg>
       </pc:sldChg>
       <pc:sldChg chg="delSp mod">
         <pc:chgData name="Rich Reba" userId="55db41ab6eb3f845" providerId="LiveId" clId="{0E19DA16-244C-5B50-BE0F-52911DD4CA7E}" dt="2026-08-06T20:27:01.277" v="28" actId="478"/>
@@ -350,107 +320,68 @@
           <pc:docMk/>
           <pc:sldMk cId="4204179867" sldId="401"/>
         </pc:sldMkLst>
-        <pc:spChg chg="del">
-          <ac:chgData name="Rich Reba" userId="55db41ab6eb3f845" providerId="LiveId" clId="{0E19DA16-244C-5B50-BE0F-52911DD4CA7E}" dt="2026-08-06T20:27:01.277" v="28" actId="478"/>
-          <ac:spMkLst>
-            <pc:docMk/>
-            <pc:sldMk cId="4204179867" sldId="401"/>
-            <ac:spMk id="2" creationId="{0568B886-68A7-D88F-D2EF-A93DC06210B0}"/>
-          </ac:spMkLst>
-        </pc:spChg>
       </pc:sldChg>
-      <pc:sldChg chg="delSp mod">
-        <pc:chgData name="Rich Reba" userId="55db41ab6eb3f845" providerId="LiveId" clId="{0E19DA16-244C-5B50-BE0F-52911DD4CA7E}" dt="2026-08-06T20:26:57.007" v="27" actId="478"/>
+      <pc:sldChg chg="delSp modSp mod">
+        <pc:chgData name="Rich Reba" userId="55db41ab6eb3f845" providerId="LiveId" clId="{0E19DA16-244C-5B50-BE0F-52911DD4CA7E}" dt="2026-08-09T15:53:38.015" v="264" actId="20577"/>
         <pc:sldMkLst>
           <pc:docMk/>
           <pc:sldMk cId="401125609" sldId="409"/>
         </pc:sldMkLst>
         <pc:spChg chg="del">
-          <ac:chgData name="Rich Reba" userId="55db41ab6eb3f845" providerId="LiveId" clId="{0E19DA16-244C-5B50-BE0F-52911DD4CA7E}" dt="2026-08-06T20:26:57.007" v="27" actId="478"/>
+          <ac:chgData name="Rich Reba" userId="55db41ab6eb3f845" providerId="LiveId" clId="{0E19DA16-244C-5B50-BE0F-52911DD4CA7E}" dt="2026-08-09T15:47:07.266" v="52" actId="478"/>
           <ac:spMkLst>
             <pc:docMk/>
             <pc:sldMk cId="401125609" sldId="409"/>
-            <ac:spMk id="2" creationId="{E1AC71C2-3A98-1EDD-95E0-0996A2B53388}"/>
+            <ac:spMk id="8" creationId="{98161617-7B83-FBD0-E788-6EDFBDE6F761}"/>
           </ac:spMkLst>
         </pc:spChg>
+        <pc:spChg chg="mod">
+          <ac:chgData name="Rich Reba" userId="55db41ab6eb3f845" providerId="LiveId" clId="{0E19DA16-244C-5B50-BE0F-52911DD4CA7E}" dt="2026-08-09T15:53:38.015" v="264" actId="20577"/>
+          <ac:spMkLst>
+            <pc:docMk/>
+            <pc:sldMk cId="401125609" sldId="409"/>
+            <ac:spMk id="96" creationId="{213A3A61-4044-D39A-7839-F3AEFE0C296B}"/>
+          </ac:spMkLst>
+        </pc:spChg>
+        <pc:graphicFrameChg chg="mod modGraphic">
+          <ac:chgData name="Rich Reba" userId="55db41ab6eb3f845" providerId="LiveId" clId="{0E19DA16-244C-5B50-BE0F-52911DD4CA7E}" dt="2026-08-09T15:49:44.453" v="132" actId="12"/>
+          <ac:graphicFrameMkLst>
+            <pc:docMk/>
+            <pc:sldMk cId="401125609" sldId="409"/>
+            <ac:graphicFrameMk id="5" creationId="{5855B0BF-5869-4C17-DDB9-4330FF90D640}"/>
+          </ac:graphicFrameMkLst>
+        </pc:graphicFrameChg>
+        <pc:picChg chg="del mod">
+          <ac:chgData name="Rich Reba" userId="55db41ab6eb3f845" providerId="LiveId" clId="{0E19DA16-244C-5B50-BE0F-52911DD4CA7E}" dt="2026-08-09T15:47:07.266" v="52" actId="478"/>
+          <ac:picMkLst>
+            <pc:docMk/>
+            <pc:sldMk cId="401125609" sldId="409"/>
+            <ac:picMk id="3" creationId="{C734C8B3-CAA6-7C3E-29FF-A014181AB53A}"/>
+          </ac:picMkLst>
+        </pc:picChg>
       </pc:sldChg>
-      <pc:sldChg chg="del">
-        <pc:chgData name="Rich Reba" userId="55db41ab6eb3f845" providerId="LiveId" clId="{0E19DA16-244C-5B50-BE0F-52911DD4CA7E}" dt="2026-08-06T20:19:11.544" v="14" actId="2696"/>
+      <pc:sldChg chg="modSp add mod">
+        <pc:chgData name="Rich Reba" userId="55db41ab6eb3f845" providerId="LiveId" clId="{0E19DA16-244C-5B50-BE0F-52911DD4CA7E}" dt="2026-08-09T15:51:46.495" v="223" actId="20577"/>
         <pc:sldMkLst>
           <pc:docMk/>
-          <pc:sldMk cId="1335389885" sldId="419"/>
+          <pc:sldMk cId="2470097404" sldId="419"/>
         </pc:sldMkLst>
-      </pc:sldChg>
-      <pc:sldChg chg="del">
-        <pc:chgData name="Rich Reba" userId="55db41ab6eb3f845" providerId="LiveId" clId="{0E19DA16-244C-5B50-BE0F-52911DD4CA7E}" dt="2026-08-06T20:19:11.568" v="22" actId="2696"/>
-        <pc:sldMkLst>
-          <pc:docMk/>
-          <pc:sldMk cId="3537629373" sldId="422"/>
-        </pc:sldMkLst>
-      </pc:sldChg>
-      <pc:sldChg chg="del">
-        <pc:chgData name="Rich Reba" userId="55db41ab6eb3f845" providerId="LiveId" clId="{0E19DA16-244C-5B50-BE0F-52911DD4CA7E}" dt="2026-08-06T20:19:11.560" v="19" actId="2696"/>
-        <pc:sldMkLst>
-          <pc:docMk/>
-          <pc:sldMk cId="681584822" sldId="423"/>
-        </pc:sldMkLst>
-      </pc:sldChg>
-      <pc:sldChg chg="del">
-        <pc:chgData name="Rich Reba" userId="55db41ab6eb3f845" providerId="LiveId" clId="{0E19DA16-244C-5B50-BE0F-52911DD4CA7E}" dt="2026-08-06T20:19:11.567" v="21" actId="2696"/>
-        <pc:sldMkLst>
-          <pc:docMk/>
-          <pc:sldMk cId="647313039" sldId="424"/>
-        </pc:sldMkLst>
-      </pc:sldChg>
-      <pc:sldChg chg="del">
-        <pc:chgData name="Rich Reba" userId="55db41ab6eb3f845" providerId="LiveId" clId="{0E19DA16-244C-5B50-BE0F-52911DD4CA7E}" dt="2026-08-06T20:19:11.575" v="23" actId="2696"/>
-        <pc:sldMkLst>
-          <pc:docMk/>
-          <pc:sldMk cId="521678706" sldId="428"/>
-        </pc:sldMkLst>
-      </pc:sldChg>
-      <pc:sldChg chg="del">
-        <pc:chgData name="Rich Reba" userId="55db41ab6eb3f845" providerId="LiveId" clId="{0E19DA16-244C-5B50-BE0F-52911DD4CA7E}" dt="2026-08-06T20:19:11.558" v="18" actId="2696"/>
-        <pc:sldMkLst>
-          <pc:docMk/>
-          <pc:sldMk cId="1588215340" sldId="429"/>
-        </pc:sldMkLst>
-      </pc:sldChg>
-      <pc:sldChg chg="del">
-        <pc:chgData name="Rich Reba" userId="55db41ab6eb3f845" providerId="LiveId" clId="{0E19DA16-244C-5B50-BE0F-52911DD4CA7E}" dt="2026-08-06T20:19:11.561" v="20" actId="2696"/>
-        <pc:sldMkLst>
-          <pc:docMk/>
-          <pc:sldMk cId="1078706708" sldId="431"/>
-        </pc:sldMkLst>
-      </pc:sldChg>
-      <pc:sldChg chg="del">
-        <pc:chgData name="Rich Reba" userId="55db41ab6eb3f845" providerId="LiveId" clId="{0E19DA16-244C-5B50-BE0F-52911DD4CA7E}" dt="2026-08-06T20:19:11.580" v="24" actId="2696"/>
-        <pc:sldMkLst>
-          <pc:docMk/>
-          <pc:sldMk cId="2186535311" sldId="432"/>
-        </pc:sldMkLst>
-      </pc:sldChg>
-      <pc:sldChg chg="del">
-        <pc:chgData name="Rich Reba" userId="55db41ab6eb3f845" providerId="LiveId" clId="{0E19DA16-244C-5B50-BE0F-52911DD4CA7E}" dt="2026-08-06T20:19:11.552" v="17" actId="2696"/>
-        <pc:sldMkLst>
-          <pc:docMk/>
-          <pc:sldMk cId="3013373299" sldId="433"/>
-        </pc:sldMkLst>
-      </pc:sldChg>
-      <pc:sldChg chg="delSp del mod">
-        <pc:chgData name="Rich Reba" userId="55db41ab6eb3f845" providerId="LiveId" clId="{0E19DA16-244C-5B50-BE0F-52911DD4CA7E}" dt="2026-08-06T20:19:11.546" v="15" actId="2696"/>
-        <pc:sldMkLst>
-          <pc:docMk/>
-          <pc:sldMk cId="756971190" sldId="434"/>
-        </pc:sldMkLst>
-        <pc:spChg chg="del">
-          <ac:chgData name="Rich Reba" userId="55db41ab6eb3f845" providerId="LiveId" clId="{0E19DA16-244C-5B50-BE0F-52911DD4CA7E}" dt="2026-08-05T20:16:55.074" v="1" actId="478"/>
+        <pc:spChg chg="mod">
+          <ac:chgData name="Rich Reba" userId="55db41ab6eb3f845" providerId="LiveId" clId="{0E19DA16-244C-5B50-BE0F-52911DD4CA7E}" dt="2026-08-09T15:51:46.495" v="223" actId="20577"/>
           <ac:spMkLst>
             <pc:docMk/>
-            <pc:sldMk cId="756971190" sldId="434"/>
-            <ac:spMk id="2" creationId="{C9FBF93F-D84F-C8FE-0DF9-0956282C6C60}"/>
+            <pc:sldMk cId="2470097404" sldId="419"/>
+            <ac:spMk id="96" creationId="{5BB72075-6DCE-1BA7-0DFB-18E282181700}"/>
           </ac:spMkLst>
         </pc:spChg>
+        <pc:graphicFrameChg chg="modGraphic">
+          <ac:chgData name="Rich Reba" userId="55db41ab6eb3f845" providerId="LiveId" clId="{0E19DA16-244C-5B50-BE0F-52911DD4CA7E}" dt="2026-08-09T15:51:15.273" v="214" actId="12"/>
+          <ac:graphicFrameMkLst>
+            <pc:docMk/>
+            <pc:sldMk cId="2470097404" sldId="419"/>
+            <ac:graphicFrameMk id="5" creationId="{0204BFE6-DD22-5495-F04C-8E7063C6DE71}"/>
+          </ac:graphicFrameMkLst>
+        </pc:graphicFrameChg>
       </pc:sldChg>
     </pc:docChg>
   </pc:docChgLst>
@@ -1607,6 +1538,407 @@
         <p:cNvPr id="1" name="Shape 92">
           <a:extLst>
             <a:ext uri="{FF2B5EF4-FFF2-40B4-BE49-F238E27FC236}">
+              <a16:creationId xmlns:a16="http://schemas.microsoft.com/office/drawing/2014/main" id="{C475177C-B137-6FF5-FED4-0934F4B85DEB}"/>
+            </a:ext>
+          </a:extLst>
+        </p:cNvPr>
+        <p:cNvGrpSpPr/>
+        <p:nvPr/>
+      </p:nvGrpSpPr>
+      <p:grpSpPr>
+        <a:xfrm>
+          <a:off x="0" y="0"/>
+          <a:ext cx="0" cy="0"/>
+          <a:chOff x="0" y="0"/>
+          <a:chExt cx="0" cy="0"/>
+        </a:xfrm>
+      </p:grpSpPr>
+      <p:sp>
+        <p:nvSpPr>
+          <p:cNvPr id="93" name="Google Shape;93;p2:notes">
+            <a:extLst>
+              <a:ext uri="{FF2B5EF4-FFF2-40B4-BE49-F238E27FC236}">
+                <a16:creationId xmlns:a16="http://schemas.microsoft.com/office/drawing/2014/main" id="{F678E11F-61A9-C022-26CC-D38B3F55B18B}"/>
+              </a:ext>
+            </a:extLst>
+          </p:cNvPr>
+          <p:cNvSpPr txBox="1">
+            <a:spLocks noGrp="1"/>
+          </p:cNvSpPr>
+          <p:nvPr>
+            <p:ph type="body" idx="1"/>
+          </p:nvPr>
+        </p:nvSpPr>
+        <p:spPr>
+          <a:xfrm>
+            <a:off x="685800" y="4343400"/>
+            <a:ext cx="5486400" cy="4114800"/>
+          </a:xfrm>
+          <a:prstGeom prst="rect">
+            <a:avLst/>
+          </a:prstGeom>
+        </p:spPr>
+        <p:txBody>
+          <a:bodyPr spcFirstLastPara="1" wrap="square" lIns="91425" tIns="91425" rIns="91425" bIns="91425" anchor="t" anchorCtr="0">
+            <a:noAutofit/>
+          </a:bodyPr>
+          <a:lstStyle/>
+          <a:p>
+            <a:pPr marL="0" lvl="0" indent="0" algn="l" rtl="0">
+              <a:spcBef>
+                <a:spcPts val="0"/>
+              </a:spcBef>
+              <a:spcAft>
+                <a:spcPts val="0"/>
+              </a:spcAft>
+              <a:buNone/>
+            </a:pPr>
+            <a:r>
+              <a:rPr lang="en-US" dirty="0"/>
+              <a:t>These are specific actions we are taking for our Services during the Launch Stage.  Actions aligned to our Consortium’s priorities are highlighted in yellow.</a:t>
+            </a:r>
+          </a:p>
+          <a:p>
+            <a:pPr marL="0" marR="0" lvl="0" indent="0" algn="l" defTabSz="914400" rtl="0" eaLnBrk="1" fontAlgn="auto" latinLnBrk="0" hangingPunct="1">
+              <a:lnSpc>
+                <a:spcPct val="100000"/>
+              </a:lnSpc>
+              <a:spcBef>
+                <a:spcPts val="0"/>
+              </a:spcBef>
+              <a:spcAft>
+                <a:spcPts val="0"/>
+              </a:spcAft>
+              <a:buClr>
+                <a:srgbClr val="000000"/>
+              </a:buClr>
+              <a:buSzPts val="1100"/>
+              <a:buFont typeface="Arial"/>
+              <a:buNone/>
+              <a:tabLst/>
+              <a:defRPr/>
+            </a:pPr>
+            <a:r>
+              <a:rPr lang="en-US" dirty="0"/>
+              <a:t>We have made progress on our top two Product priorities:  using LPM, and identifying the right Collaboration Platforms </a:t>
+            </a:r>
+            <a:r>
+              <a:rPr kumimoji="0" lang="en-US" sz="1100" b="0" i="0" u="none" strike="noStrike" kern="1200" cap="none" spc="0" normalizeH="0" baseline="0" noProof="0" dirty="0">
+                <a:ln>
+                  <a:noFill/>
+                </a:ln>
+                <a:solidFill>
+                  <a:schemeClr val="tx1"/>
+                </a:solidFill>
+                <a:effectLst/>
+                <a:uLnTx/>
+                <a:uFillTx/>
+                <a:latin typeface="Aptos" panose="02110004020202020204"/>
+                <a:cs typeface="Arial"/>
+                <a:sym typeface="Arial"/>
+              </a:rPr>
+              <a:t>t</a:t>
+            </a:r>
+            <a:r>
+              <a:rPr kumimoji="0" lang="en-US" sz="1100" b="0" i="0" u="none" strike="noStrike" kern="1200" cap="none" spc="0" normalizeH="0" baseline="0" noProof="0" dirty="0">
+                <a:ln>
+                  <a:noFill/>
+                </a:ln>
+                <a:solidFill>
+                  <a:schemeClr val="tx1"/>
+                </a:solidFill>
+                <a:effectLst/>
+                <a:uLnTx/>
+                <a:uFillTx/>
+                <a:latin typeface="Aptos" panose="02110004020202020204"/>
+                <a:ea typeface="Arial"/>
+                <a:cs typeface="Arial"/>
+                <a:sym typeface="Arial"/>
+              </a:rPr>
+              <a:t>o connect our network and be credible</a:t>
+            </a:r>
+          </a:p>
+          <a:p>
+            <a:pPr marL="0" marR="0" lvl="0" indent="0" algn="l" defTabSz="914400" rtl="0" eaLnBrk="1" fontAlgn="auto" latinLnBrk="0" hangingPunct="1">
+              <a:lnSpc>
+                <a:spcPct val="100000"/>
+              </a:lnSpc>
+              <a:spcBef>
+                <a:spcPts val="0"/>
+              </a:spcBef>
+              <a:spcAft>
+                <a:spcPts val="0"/>
+              </a:spcAft>
+              <a:buClr>
+                <a:srgbClr val="000000"/>
+              </a:buClr>
+              <a:buSzPts val="1100"/>
+              <a:buFont typeface="Arial"/>
+              <a:buNone/>
+              <a:tabLst/>
+              <a:defRPr/>
+            </a:pPr>
+            <a:r>
+              <a:rPr kumimoji="0" lang="en-US" sz="1100" b="0" i="0" u="none" strike="noStrike" kern="1200" cap="none" spc="0" normalizeH="0" baseline="0" noProof="0" dirty="0">
+                <a:ln>
+                  <a:noFill/>
+                </a:ln>
+                <a:solidFill>
+                  <a:schemeClr val="tx1"/>
+                </a:solidFill>
+                <a:effectLst/>
+                <a:uLnTx/>
+                <a:uFillTx/>
+                <a:latin typeface="Aptos" panose="02110004020202020204"/>
+                <a:ea typeface="Arial"/>
+                <a:cs typeface="Arial"/>
+                <a:sym typeface="Arial"/>
+              </a:rPr>
+              <a:t>To win advocacy from credible industry influencers and go viral, we must hone our messages and launch a campaign</a:t>
+            </a:r>
+          </a:p>
+          <a:p>
+            <a:pPr marL="0" marR="0" lvl="0" indent="0" algn="l" defTabSz="914400" rtl="0" eaLnBrk="1" fontAlgn="auto" latinLnBrk="0" hangingPunct="1">
+              <a:lnSpc>
+                <a:spcPct val="100000"/>
+              </a:lnSpc>
+              <a:spcBef>
+                <a:spcPts val="0"/>
+              </a:spcBef>
+              <a:spcAft>
+                <a:spcPts val="0"/>
+              </a:spcAft>
+              <a:buClr>
+                <a:srgbClr val="000000"/>
+              </a:buClr>
+              <a:buSzPts val="1100"/>
+              <a:buFont typeface="Arial"/>
+              <a:buNone/>
+              <a:tabLst/>
+              <a:defRPr/>
+            </a:pPr>
+            <a:r>
+              <a:rPr kumimoji="0" lang="en-US" sz="1100" b="0" i="0" u="none" strike="noStrike" kern="1200" cap="none" spc="0" normalizeH="0" baseline="0" noProof="0" dirty="0">
+                <a:ln>
+                  <a:noFill/>
+                </a:ln>
+                <a:solidFill>
+                  <a:schemeClr val="tx1"/>
+                </a:solidFill>
+                <a:effectLst/>
+                <a:uLnTx/>
+                <a:uFillTx/>
+                <a:latin typeface="Aptos" panose="02110004020202020204"/>
+                <a:ea typeface="Arial"/>
+                <a:cs typeface="Arial"/>
+                <a:sym typeface="Arial"/>
+              </a:rPr>
+              <a:t>To scale quickly, we must learn from leaders experienced in similar non-profits, especially ASUG and the Bender Leadership Academy</a:t>
+            </a:r>
+          </a:p>
+          <a:p>
+            <a:pPr marL="0" marR="0" lvl="0" indent="0" algn="l" defTabSz="914400" rtl="0" eaLnBrk="1" fontAlgn="auto" latinLnBrk="0" hangingPunct="1">
+              <a:lnSpc>
+                <a:spcPct val="100000"/>
+              </a:lnSpc>
+              <a:spcBef>
+                <a:spcPts val="0"/>
+              </a:spcBef>
+              <a:spcAft>
+                <a:spcPts val="0"/>
+              </a:spcAft>
+              <a:buClr>
+                <a:srgbClr val="000000"/>
+              </a:buClr>
+              <a:buSzPts val="1100"/>
+              <a:buFont typeface="Arial"/>
+              <a:buNone/>
+              <a:tabLst/>
+              <a:defRPr/>
+            </a:pPr>
+            <a:r>
+              <a:rPr lang="en-US" sz="1100" b="0" i="0" u="none" strike="noStrike" kern="1200" cap="none" dirty="0">
+                <a:solidFill>
+                  <a:schemeClr val="tx1"/>
+                </a:solidFill>
+                <a:latin typeface="Aptos" panose="02110004020202020204"/>
+                <a:ea typeface="Arial"/>
+                <a:cs typeface="Arial"/>
+                <a:sym typeface="Arial"/>
+              </a:rPr>
+              <a:t>To help us scale and be credible, we must experiment with and practice using AI for all of these activities</a:t>
+            </a:r>
+            <a:endParaRPr lang="en-US" dirty="0">
+              <a:solidFill>
+                <a:schemeClr val="tx1"/>
+              </a:solidFill>
+            </a:endParaRPr>
+          </a:p>
+          <a:p>
+            <a:pPr marL="0" marR="0" lvl="0" indent="0" algn="l" defTabSz="914400" rtl="0" eaLnBrk="1" fontAlgn="auto" latinLnBrk="0" hangingPunct="1">
+              <a:lnSpc>
+                <a:spcPct val="100000"/>
+              </a:lnSpc>
+              <a:spcBef>
+                <a:spcPts val="0"/>
+              </a:spcBef>
+              <a:spcAft>
+                <a:spcPts val="0"/>
+              </a:spcAft>
+              <a:buClr>
+                <a:srgbClr val="000000"/>
+              </a:buClr>
+              <a:buSzPts val="1100"/>
+              <a:buFont typeface="Arial"/>
+              <a:buNone/>
+              <a:tabLst/>
+              <a:defRPr/>
+            </a:pPr>
+            <a:endParaRPr lang="en-US" dirty="0">
+              <a:solidFill>
+                <a:schemeClr val="tx1"/>
+              </a:solidFill>
+            </a:endParaRPr>
+          </a:p>
+          <a:p>
+            <a:pPr marL="0" marR="0" lvl="0" indent="0" algn="l" defTabSz="914400" rtl="0" eaLnBrk="1" fontAlgn="auto" latinLnBrk="0" hangingPunct="1">
+              <a:lnSpc>
+                <a:spcPct val="100000"/>
+              </a:lnSpc>
+              <a:spcBef>
+                <a:spcPts val="0"/>
+              </a:spcBef>
+              <a:spcAft>
+                <a:spcPts val="0"/>
+              </a:spcAft>
+              <a:buClr>
+                <a:srgbClr val="000000"/>
+              </a:buClr>
+              <a:buSzPts val="1100"/>
+              <a:buFont typeface="Arial"/>
+              <a:buNone/>
+              <a:tabLst/>
+              <a:defRPr/>
+            </a:pPr>
+            <a:endParaRPr lang="en-US" dirty="0">
+              <a:solidFill>
+                <a:schemeClr val="tx1"/>
+              </a:solidFill>
+            </a:endParaRPr>
+          </a:p>
+          <a:p>
+            <a:pPr marL="0" marR="0" lvl="0" indent="0" algn="l" defTabSz="914400" rtl="0" eaLnBrk="1" fontAlgn="auto" latinLnBrk="0" hangingPunct="1">
+              <a:lnSpc>
+                <a:spcPct val="100000"/>
+              </a:lnSpc>
+              <a:spcBef>
+                <a:spcPts val="0"/>
+              </a:spcBef>
+              <a:spcAft>
+                <a:spcPts val="0"/>
+              </a:spcAft>
+              <a:buClr>
+                <a:srgbClr val="000000"/>
+              </a:buClr>
+              <a:buSzPts val="1100"/>
+              <a:buFont typeface="Arial"/>
+              <a:buNone/>
+              <a:tabLst/>
+              <a:defRPr/>
+            </a:pPr>
+            <a:endParaRPr kumimoji="0" lang="en-US" sz="1100" b="0" i="0" u="none" strike="noStrike" kern="1200" cap="none" spc="0" normalizeH="0" baseline="0" noProof="0" dirty="0">
+              <a:ln>
+                <a:noFill/>
+              </a:ln>
+              <a:solidFill>
+                <a:schemeClr val="tx1"/>
+              </a:solidFill>
+              <a:effectLst/>
+              <a:uLnTx/>
+              <a:uFillTx/>
+              <a:latin typeface="Aptos" panose="02110004020202020204"/>
+              <a:ea typeface="Arial"/>
+              <a:cs typeface="Arial"/>
+              <a:sym typeface="Arial"/>
+            </a:endParaRPr>
+          </a:p>
+        </p:txBody>
+      </p:sp>
+      <p:sp>
+        <p:nvSpPr>
+          <p:cNvPr id="94" name="Google Shape;94;p2:notes">
+            <a:extLst>
+              <a:ext uri="{FF2B5EF4-FFF2-40B4-BE49-F238E27FC236}">
+                <a16:creationId xmlns:a16="http://schemas.microsoft.com/office/drawing/2014/main" id="{E21D8678-910C-3FFB-BE6D-C6AF4F27C994}"/>
+              </a:ext>
+            </a:extLst>
+          </p:cNvPr>
+          <p:cNvSpPr>
+            <a:spLocks noGrp="1" noRot="1" noChangeAspect="1"/>
+          </p:cNvSpPr>
+          <p:nvPr>
+            <p:ph type="sldImg" idx="2"/>
+          </p:nvPr>
+        </p:nvSpPr>
+        <p:spPr>
+          <a:xfrm>
+            <a:off x="381000" y="685800"/>
+            <a:ext cx="6096000" cy="3429000"/>
+          </a:xfrm>
+          <a:custGeom>
+            <a:avLst/>
+            <a:gdLst/>
+            <a:ahLst/>
+            <a:cxnLst/>
+            <a:rect l="l" t="t" r="r" b="b"/>
+            <a:pathLst>
+              <a:path w="120000" h="120000" extrusionOk="0">
+                <a:moveTo>
+                  <a:pt x="0" y="0"/>
+                </a:moveTo>
+                <a:lnTo>
+                  <a:pt x="120000" y="0"/>
+                </a:lnTo>
+                <a:lnTo>
+                  <a:pt x="120000" y="120000"/>
+                </a:lnTo>
+                <a:lnTo>
+                  <a:pt x="0" y="120000"/>
+                </a:lnTo>
+                <a:close/>
+              </a:path>
+            </a:pathLst>
+          </a:custGeom>
+        </p:spPr>
+        <p:txBody>
+          <a:bodyPr/>
+          <a:lstStyle/>
+          <a:p>
+            <a:endParaRPr lang="en-US"/>
+          </a:p>
+        </p:txBody>
+      </p:sp>
+    </p:spTree>
+    <p:extLst>
+      <p:ext uri="{BB962C8B-B14F-4D97-AF65-F5344CB8AC3E}">
+        <p14:creationId xmlns:p14="http://schemas.microsoft.com/office/powerpoint/2010/main" val="2995733651"/>
+      </p:ext>
+    </p:extLst>
+  </p:cSld>
+  <p:clrMapOvr>
+    <a:masterClrMapping/>
+  </p:clrMapOvr>
+</p:notes>
+</file>
+
+<file path=ppt/notesSlides/notesSlide7.xml><?xml version="1.0" encoding="utf-8"?>
+<p:notes xmlns:a="http://schemas.openxmlformats.org/drawingml/2006/main" xmlns:r="http://schemas.openxmlformats.org/officeDocument/2006/relationships" xmlns:p="http://schemas.openxmlformats.org/presentationml/2006/main" showMasterSp="0" showMasterPhAnim="0">
+  <p:cSld>
+    <p:spTree>
+      <p:nvGrpSpPr>
+        <p:cNvPr id="1" name="Shape 92">
+          <a:extLst>
+            <a:ext uri="{FF2B5EF4-FFF2-40B4-BE49-F238E27FC236}">
               <a16:creationId xmlns:a16="http://schemas.microsoft.com/office/drawing/2014/main" id="{FEE2389B-20BC-28BE-17DD-C7442B7B6342}"/>
             </a:ext>
           </a:extLst>
@@ -2000,7 +2332,7 @@
 </p:notes>
 </file>
 
-<file path=ppt/notesSlides/notesSlide7.xml><?xml version="1.0" encoding="utf-8"?>
+<file path=ppt/notesSlides/notesSlide8.xml><?xml version="1.0" encoding="utf-8"?>
 <p:notes xmlns:a="http://schemas.openxmlformats.org/drawingml/2006/main" xmlns:r="http://schemas.openxmlformats.org/officeDocument/2006/relationships" xmlns:p="http://schemas.openxmlformats.org/presentationml/2006/main" showMasterSp="0" showMasterPhAnim="0">
   <p:cSld>
     <p:spTree>
@@ -2138,7 +2470,7 @@
 </p:notes>
 </file>
 
-<file path=ppt/notesSlides/notesSlide8.xml><?xml version="1.0" encoding="utf-8"?>
+<file path=ppt/notesSlides/notesSlide9.xml><?xml version="1.0" encoding="utf-8"?>
 <p:notes xmlns:a="http://schemas.openxmlformats.org/drawingml/2006/main" xmlns:r="http://schemas.openxmlformats.org/officeDocument/2006/relationships" xmlns:p="http://schemas.openxmlformats.org/presentationml/2006/main" showMasterSp="0" showMasterPhAnim="0">
   <p:cSld>
     <p:spTree>
@@ -3704,7 +4036,7 @@
           <a:p>
             <a:fld id="{9DC09AF2-51A2-8243-A29F-680495D2BD2C}" type="datetimeFigureOut">
               <a:rPr lang="en-US" smtClean="0"/>
-              <a:t>8/6/26</a:t>
+              <a:t>8/9/26</a:t>
             </a:fld>
             <a:endParaRPr lang="en-US"/>
           </a:p>
@@ -12680,6 +13012,174 @@
         </p:txBody>
       </p:sp>
     </p:spTree>
+  </p:cSld>
+  <p:clrMapOvr>
+    <a:masterClrMapping/>
+  </p:clrMapOvr>
+</p:sld>
+</file>
+
+<file path=ppt/slides/slide10.xml><?xml version="1.0" encoding="utf-8"?>
+<p:sld xmlns:a="http://schemas.openxmlformats.org/drawingml/2006/main" xmlns:r="http://schemas.openxmlformats.org/officeDocument/2006/relationships" xmlns:p="http://schemas.openxmlformats.org/presentationml/2006/main">
+  <p:cSld>
+    <p:spTree>
+      <p:nvGrpSpPr>
+        <p:cNvPr id="1" name="Shape 120">
+          <a:extLst>
+            <a:ext uri="{FF2B5EF4-FFF2-40B4-BE49-F238E27FC236}">
+              <a16:creationId xmlns:a16="http://schemas.microsoft.com/office/drawing/2014/main" id="{ECDE25D5-7ABB-9ADA-350B-500231E65541}"/>
+            </a:ext>
+          </a:extLst>
+        </p:cNvPr>
+        <p:cNvGrpSpPr/>
+        <p:nvPr/>
+      </p:nvGrpSpPr>
+      <p:grpSpPr>
+        <a:xfrm>
+          <a:off x="0" y="0"/>
+          <a:ext cx="0" cy="0"/>
+          <a:chOff x="0" y="0"/>
+          <a:chExt cx="0" cy="0"/>
+        </a:xfrm>
+      </p:grpSpPr>
+      <p:sp>
+        <p:nvSpPr>
+          <p:cNvPr id="121" name="Google Shape;121;p5">
+            <a:extLst>
+              <a:ext uri="{FF2B5EF4-FFF2-40B4-BE49-F238E27FC236}">
+                <a16:creationId xmlns:a16="http://schemas.microsoft.com/office/drawing/2014/main" id="{D1FD5753-66B3-EA4B-4895-9891C1AB6723}"/>
+              </a:ext>
+            </a:extLst>
+          </p:cNvPr>
+          <p:cNvSpPr txBox="1">
+            <a:spLocks noGrp="1"/>
+          </p:cNvSpPr>
+          <p:nvPr>
+            <p:ph type="title"/>
+          </p:nvPr>
+        </p:nvSpPr>
+        <p:spPr>
+          <a:xfrm>
+            <a:off x="838199" y="365125"/>
+            <a:ext cx="8950569" cy="1325563"/>
+          </a:xfrm>
+          <a:prstGeom prst="rect">
+            <a:avLst/>
+          </a:prstGeom>
+          <a:noFill/>
+          <a:ln>
+            <a:noFill/>
+          </a:ln>
+        </p:spPr>
+        <p:txBody>
+          <a:bodyPr spcFirstLastPara="1" wrap="square" lIns="91425" tIns="45700" rIns="91425" bIns="45700" anchor="ctr" anchorCtr="0">
+            <a:normAutofit/>
+          </a:bodyPr>
+          <a:lstStyle/>
+          <a:p>
+            <a:pPr marL="0" lvl="0" indent="0" algn="l" rtl="0">
+              <a:lnSpc>
+                <a:spcPct val="90000"/>
+              </a:lnSpc>
+              <a:spcBef>
+                <a:spcPts val="0"/>
+              </a:spcBef>
+              <a:spcAft>
+                <a:spcPts val="0"/>
+              </a:spcAft>
+              <a:buClr>
+                <a:schemeClr val="dk1"/>
+              </a:buClr>
+              <a:buSzPts val="4400"/>
+              <a:buFont typeface="Calibri"/>
+              <a:buNone/>
+            </a:pPr>
+            <a:r>
+              <a:rPr lang="en-US" dirty="0"/>
+              <a:t>Portfolio Kanban Reference</a:t>
+            </a:r>
+            <a:endParaRPr dirty="0"/>
+          </a:p>
+        </p:txBody>
+      </p:sp>
+      <p:pic>
+        <p:nvPicPr>
+          <p:cNvPr id="32" name="Picture 31">
+            <a:extLst>
+              <a:ext uri="{FF2B5EF4-FFF2-40B4-BE49-F238E27FC236}">
+                <a16:creationId xmlns:a16="http://schemas.microsoft.com/office/drawing/2014/main" id="{D3616900-0C58-1E90-22AE-07E41FA90C5C}"/>
+              </a:ext>
+            </a:extLst>
+          </p:cNvPr>
+          <p:cNvPicPr>
+            <a:picLocks noChangeAspect="1"/>
+          </p:cNvPicPr>
+          <p:nvPr/>
+        </p:nvPicPr>
+        <p:blipFill>
+          <a:blip r:embed="rId3"/>
+          <a:stretch>
+            <a:fillRect/>
+          </a:stretch>
+        </p:blipFill>
+        <p:spPr>
+          <a:xfrm>
+            <a:off x="116361" y="1609391"/>
+            <a:ext cx="11959278" cy="4748877"/>
+          </a:xfrm>
+          <a:prstGeom prst="rect">
+            <a:avLst/>
+          </a:prstGeom>
+        </p:spPr>
+      </p:pic>
+      <p:sp>
+        <p:nvSpPr>
+          <p:cNvPr id="2" name="TextBox 1">
+            <a:extLst>
+              <a:ext uri="{FF2B5EF4-FFF2-40B4-BE49-F238E27FC236}">
+                <a16:creationId xmlns:a16="http://schemas.microsoft.com/office/drawing/2014/main" id="{FA549193-7BF6-72BD-7395-1DB5F0173929}"/>
+              </a:ext>
+            </a:extLst>
+          </p:cNvPr>
+          <p:cNvSpPr txBox="1"/>
+          <p:nvPr/>
+        </p:nvSpPr>
+        <p:spPr>
+          <a:xfrm>
+            <a:off x="385763" y="6050491"/>
+            <a:ext cx="5867312" cy="307777"/>
+          </a:xfrm>
+          <a:prstGeom prst="rect">
+            <a:avLst/>
+          </a:prstGeom>
+          <a:noFill/>
+        </p:spPr>
+        <p:txBody>
+          <a:bodyPr wrap="none" rtlCol="0">
+            <a:spAutoFit/>
+          </a:bodyPr>
+          <a:lstStyle/>
+          <a:p>
+            <a:r>
+              <a:rPr lang="en-US" dirty="0"/>
+              <a:t>To learn more, visit the </a:t>
+            </a:r>
+            <a:r>
+              <a:rPr lang="en-US" dirty="0">
+                <a:hlinkClick r:id="rId4"/>
+              </a:rPr>
+              <a:t>Scaled Agile Framework Portfolio Backlog article</a:t>
+            </a:r>
+            <a:endParaRPr lang="en-US" dirty="0"/>
+          </a:p>
+        </p:txBody>
+      </p:sp>
+    </p:spTree>
+    <p:extLst>
+      <p:ext uri="{BB962C8B-B14F-4D97-AF65-F5344CB8AC3E}">
+        <p14:creationId xmlns:p14="http://schemas.microsoft.com/office/powerpoint/2010/main" val="3601186110"/>
+      </p:ext>
+    </p:extLst>
   </p:cSld>
   <p:clrMapOvr>
     <a:masterClrMapping/>
@@ -19182,7 +19682,7 @@
         <p:cNvPr id="1" name="Shape 95">
           <a:extLst>
             <a:ext uri="{FF2B5EF4-FFF2-40B4-BE49-F238E27FC236}">
-              <a16:creationId xmlns:a16="http://schemas.microsoft.com/office/drawing/2014/main" id="{9CF0030E-C778-6057-7F00-D64497814302}"/>
+              <a16:creationId xmlns:a16="http://schemas.microsoft.com/office/drawing/2014/main" id="{22D3A38C-4689-0FCF-EAD8-339EAB86A977}"/>
             </a:ext>
           </a:extLst>
         </p:cNvPr>
@@ -19197,42 +19697,12 @@
           <a:chExt cx="0" cy="0"/>
         </a:xfrm>
       </p:grpSpPr>
-      <p:pic>
-        <p:nvPicPr>
-          <p:cNvPr id="3" name="Picture 2">
-            <a:extLst>
-              <a:ext uri="{FF2B5EF4-FFF2-40B4-BE49-F238E27FC236}">
-                <a16:creationId xmlns:a16="http://schemas.microsoft.com/office/drawing/2014/main" id="{C734C8B3-CAA6-7C3E-29FF-A014181AB53A}"/>
-              </a:ext>
-            </a:extLst>
-          </p:cNvPr>
-          <p:cNvPicPr>
-            <a:picLocks noChangeAspect="1"/>
-          </p:cNvPicPr>
-          <p:nvPr/>
-        </p:nvPicPr>
-        <p:blipFill>
-          <a:blip r:embed="rId3"/>
-          <a:stretch>
-            <a:fillRect/>
-          </a:stretch>
-        </p:blipFill>
-        <p:spPr>
-          <a:xfrm>
-            <a:off x="0" y="-7948"/>
-            <a:ext cx="1586753" cy="892549"/>
-          </a:xfrm>
-          <a:prstGeom prst="rect">
-            <a:avLst/>
-          </a:prstGeom>
-        </p:spPr>
-      </p:pic>
       <p:sp>
         <p:nvSpPr>
           <p:cNvPr id="96" name="Google Shape;96;p2">
             <a:extLst>
               <a:ext uri="{FF2B5EF4-FFF2-40B4-BE49-F238E27FC236}">
-                <a16:creationId xmlns:a16="http://schemas.microsoft.com/office/drawing/2014/main" id="{213A3A61-4044-D39A-7839-F3AEFE0C296B}"/>
+                <a16:creationId xmlns:a16="http://schemas.microsoft.com/office/drawing/2014/main" id="{5BB72075-6DCE-1BA7-0DFB-18E282181700}"/>
               </a:ext>
             </a:extLst>
           </p:cNvPr>
@@ -19277,7 +19747,14 @@
             </a:pPr>
             <a:r>
               <a:rPr lang="en-US" dirty="0"/>
-              <a:t>Roadmap to Launch (v1 Services)</a:t>
+              <a:t>Roadmap to Launch (Horizon 1)</a:t>
+            </a:r>
+            <a:br>
+              <a:rPr lang="en-US" dirty="0"/>
+            </a:br>
+            <a:r>
+              <a:rPr lang="en-US" dirty="0"/>
+              <a:t>Baseline</a:t>
             </a:r>
             <a:endParaRPr dirty="0"/>
           </a:p>
@@ -19288,7 +19765,7 @@
           <p:cNvPr id="5" name="Table 4">
             <a:extLst>
               <a:ext uri="{FF2B5EF4-FFF2-40B4-BE49-F238E27FC236}">
-                <a16:creationId xmlns:a16="http://schemas.microsoft.com/office/drawing/2014/main" id="{5855B0BF-5869-4C17-DDB9-4330FF90D640}"/>
+                <a16:creationId xmlns:a16="http://schemas.microsoft.com/office/drawing/2014/main" id="{0204BFE6-DD22-5495-F04C-8E7063C6DE71}"/>
               </a:ext>
             </a:extLst>
           </p:cNvPr>
@@ -19298,14 +19775,14 @@
           <p:nvPr>
             <p:extLst>
               <p:ext uri="{D42A27DB-BD31-4B8C-83A1-F6EECF244321}">
-                <p14:modId xmlns:p14="http://schemas.microsoft.com/office/powerpoint/2010/main" val="617839243"/>
+                <p14:modId xmlns:p14="http://schemas.microsoft.com/office/powerpoint/2010/main" val="4152647132"/>
               </p:ext>
             </p:extLst>
           </p:nvPr>
         </p:nvGraphicFramePr>
         <p:xfrm>
           <a:off x="410934" y="1560399"/>
-          <a:ext cx="11370132" cy="4851554"/>
+          <a:ext cx="11370132" cy="5025887"/>
         </p:xfrm>
         <a:graphic>
           <a:graphicData uri="http://schemas.openxmlformats.org/drawingml/2006/table">
@@ -19463,7 +19940,7 @@
                   </a:ext>
                 </a:extLst>
               </a:tr>
-              <a:tr h="900682">
+              <a:tr h="723820">
                 <a:tc>
                   <a:txBody>
                     <a:bodyPr/>
@@ -19471,7 +19948,7 @@
                     <a:p>
                       <a:r>
                         <a:rPr lang="en-US" sz="2000" b="1" dirty="0"/>
-                        <a:t>All Services</a:t>
+                        <a:t>Professional Networking</a:t>
                       </a:r>
                     </a:p>
                   </a:txBody>
@@ -19520,72 +19997,108 @@
                     <a:lstStyle/>
                     <a:p>
                       <a:pPr marL="171450" lvl="2" indent="-171450">
-                        <a:buFont typeface="Wingdings" pitchFamily="2" charset="2"/>
-                        <a:buChar char="q"/>
+                        <a:buFont typeface="Arial" panose="020B0604020202020204" pitchFamily="34" charset="0"/>
+                        <a:buChar char="•"/>
                         <a:tabLst/>
                       </a:pPr>
                       <a:r>
-                        <a:rPr lang="en-US" sz="1200" b="0" dirty="0">
+                        <a:rPr lang="en-US" sz="1200" b="0" i="0" u="none" strike="noStrike" cap="none" dirty="0">
                           <a:solidFill>
                             <a:schemeClr val="tx1"/>
                           </a:solidFill>
-                          <a:highlight>
-                            <a:srgbClr val="FFFF00"/>
-                          </a:highlight>
+                          <a:effectLst/>
+                          <a:latin typeface="+mn-lt"/>
+                          <a:ea typeface="+mn-ea"/>
+                          <a:cs typeface="+mn-cs"/>
+                          <a:sym typeface="Arial"/>
                         </a:rPr>
-                        <a:t>Use Lean Product Management to publish Services info on our LinkedIn page</a:t>
+                        <a:t>Learn from ASUG, Toastmasters, and PMI leaders how they grew their networks</a:t>
                       </a:r>
                     </a:p>
                     <a:p>
                       <a:pPr marL="171450" lvl="2" indent="-171450">
-                        <a:buFont typeface="Wingdings" pitchFamily="2" charset="2"/>
-                        <a:buChar char="ü"/>
+                        <a:buFont typeface="Arial" panose="020B0604020202020204" pitchFamily="34" charset="0"/>
+                        <a:buChar char="•"/>
                         <a:tabLst/>
                       </a:pPr>
                       <a:r>
-                        <a:rPr lang="en-US" sz="1200" b="0" dirty="0">
+                        <a:rPr lang="en-US" sz="1200" b="0" i="0" u="none" strike="noStrike" cap="none" dirty="0">
                           <a:solidFill>
                             <a:schemeClr val="tx1"/>
                           </a:solidFill>
-                          <a:highlight>
-                            <a:srgbClr val="FFFF00"/>
-                          </a:highlight>
+                          <a:effectLst/>
+                          <a:latin typeface="+mn-lt"/>
+                          <a:ea typeface="+mn-ea"/>
+                          <a:cs typeface="+mn-cs"/>
+                          <a:sym typeface="Arial"/>
                         </a:rPr>
-                        <a:t>Explore low-cost options for setting up a website (e.g., Wordpress)</a:t>
+                        <a:t>Grow the number of Subscribers to 100 via the Board of Directors</a:t>
                       </a:r>
                     </a:p>
                     <a:p>
                       <a:pPr marL="171450" lvl="2" indent="-171450">
-                        <a:buFont typeface="Wingdings" pitchFamily="2" charset="2"/>
-                        <a:buChar char="q"/>
+                        <a:buFont typeface="Arial" panose="020B0604020202020204" pitchFamily="34" charset="0"/>
+                        <a:buChar char="•"/>
                         <a:tabLst/>
                       </a:pPr>
                       <a:r>
-                        <a:rPr lang="en-US" sz="1200" b="0" dirty="0">
+                        <a:rPr lang="en-US" sz="1200" b="0" i="0" u="none" strike="noStrike" cap="none" dirty="0">
                           <a:solidFill>
                             <a:schemeClr val="tx1"/>
                           </a:solidFill>
-                          <a:highlight>
-                            <a:srgbClr val="FFFF00"/>
-                          </a:highlight>
+                          <a:effectLst/>
+                          <a:latin typeface="+mn-lt"/>
+                          <a:ea typeface="+mn-ea"/>
+                          <a:cs typeface="+mn-cs"/>
+                          <a:sym typeface="Arial"/>
                         </a:rPr>
-                        <a:t>Experiment with and practice using AI to help our Consortium scale</a:t>
+                        <a:t>Explore platforms to enhance collaboration (e.g., LinkedIn Groups, Discord)</a:t>
                       </a:r>
                     </a:p>
                     <a:p>
                       <a:pPr marL="171450" lvl="2" indent="-171450">
-                        <a:buFont typeface="Wingdings" pitchFamily="2" charset="2"/>
-                        <a:buChar char="q"/>
+                        <a:buFont typeface="Arial" panose="020B0604020202020204" pitchFamily="34" charset="0"/>
+                        <a:buChar char="•"/>
                         <a:tabLst/>
                       </a:pPr>
                       <a:r>
-                        <a:rPr lang="en-US" sz="1200" b="0" dirty="0">
+                        <a:rPr lang="en-US" sz="1200" b="0" i="0" u="none" strike="noStrike" cap="none" dirty="0">
                           <a:solidFill>
                             <a:schemeClr val="tx1"/>
                           </a:solidFill>
+                          <a:effectLst/>
+                          <a:latin typeface="+mn-lt"/>
+                          <a:ea typeface="+mn-ea"/>
+                          <a:cs typeface="+mn-cs"/>
+                          <a:sym typeface="Arial"/>
                         </a:rPr>
-                        <a:t>Explore ideas for raising seed money (donations and grants)</a:t>
+                        <a:t>Prepare a campaign to grow the number of Subscribers to 300</a:t>
                       </a:r>
+                    </a:p>
+                    <a:p>
+                      <a:pPr marL="171450" lvl="2" indent="-171450">
+                        <a:buFont typeface="Arial" panose="020B0604020202020204" pitchFamily="34" charset="0"/>
+                        <a:buChar char="•"/>
+                        <a:tabLst/>
+                      </a:pPr>
+                      <a:r>
+                        <a:rPr lang="en-US" sz="1200" b="0" i="0" u="none" strike="noStrike" cap="none" dirty="0">
+                          <a:solidFill>
+                            <a:schemeClr val="tx1"/>
+                          </a:solidFill>
+                          <a:effectLst/>
+                          <a:latin typeface="+mn-lt"/>
+                          <a:ea typeface="+mn-ea"/>
+                          <a:cs typeface="+mn-cs"/>
+                          <a:sym typeface="Arial"/>
+                        </a:rPr>
+                        <a:t>Explore Freemium options for generating revenues (e.g., local chapters)</a:t>
+                      </a:r>
+                      <a:endParaRPr lang="en-US" sz="1200" b="0" dirty="0">
+                        <a:solidFill>
+                          <a:schemeClr val="tx1"/>
+                        </a:solidFill>
+                      </a:endParaRPr>
                     </a:p>
                   </a:txBody>
                   <a:tcPr>
@@ -19645,8 +20158,8 @@
                         <a:buClr>
                           <a:srgbClr val="000000"/>
                         </a:buClr>
-                        <a:buFont typeface="Wingdings" pitchFamily="2" charset="2"/>
-                        <a:buChar char="q"/>
+                        <a:buFont typeface="Arial" panose="020B0604020202020204" pitchFamily="34" charset="0"/>
+                        <a:buChar char="•"/>
                         <a:tabLst/>
                       </a:pPr>
                       <a:r>
@@ -19654,9 +20167,975 @@
                           <a:solidFill>
                             <a:schemeClr val="tx1"/>
                           </a:solidFill>
-                          <a:highlight>
-                            <a:srgbClr val="FFFF00"/>
-                          </a:highlight>
+                          <a:latin typeface="+mn-lt"/>
+                          <a:ea typeface="+mn-ea"/>
+                          <a:cs typeface="+mn-cs"/>
+                          <a:sym typeface="Arial"/>
+                        </a:rPr>
+                        <a:t>Identify Leader for Professional Network Service</a:t>
+                      </a:r>
+                    </a:p>
+                    <a:p>
+                      <a:pPr marL="171450" marR="0" lvl="2" indent="-171450" algn="l" rtl="0">
+                        <a:lnSpc>
+                          <a:spcPct val="100000"/>
+                        </a:lnSpc>
+                        <a:spcBef>
+                          <a:spcPts val="0"/>
+                        </a:spcBef>
+                        <a:spcAft>
+                          <a:spcPts val="0"/>
+                        </a:spcAft>
+                        <a:buClr>
+                          <a:srgbClr val="000000"/>
+                        </a:buClr>
+                        <a:buFont typeface="Arial" panose="020B0604020202020204" pitchFamily="34" charset="0"/>
+                        <a:buChar char="•"/>
+                        <a:tabLst/>
+                      </a:pPr>
+                      <a:r>
+                        <a:rPr lang="en-US" sz="1200" b="0" i="0" u="none" strike="noStrike" cap="none" dirty="0">
+                          <a:solidFill>
+                            <a:schemeClr val="tx1"/>
+                          </a:solidFill>
+                          <a:latin typeface="+mn-lt"/>
+                          <a:ea typeface="+mn-ea"/>
+                          <a:cs typeface="+mn-cs"/>
+                          <a:sym typeface="Arial"/>
+                        </a:rPr>
+                        <a:t>Run campaigns to grow the number of Subscribers to 300 and then to 1,000</a:t>
+                      </a:r>
+                    </a:p>
+                    <a:p>
+                      <a:pPr marL="171450" marR="0" lvl="2" indent="-171450" algn="l" rtl="0">
+                        <a:lnSpc>
+                          <a:spcPct val="100000"/>
+                        </a:lnSpc>
+                        <a:spcBef>
+                          <a:spcPts val="0"/>
+                        </a:spcBef>
+                        <a:spcAft>
+                          <a:spcPts val="0"/>
+                        </a:spcAft>
+                        <a:buClr>
+                          <a:srgbClr val="000000"/>
+                        </a:buClr>
+                        <a:buFont typeface="Arial" panose="020B0604020202020204" pitchFamily="34" charset="0"/>
+                        <a:buChar char="•"/>
+                        <a:tabLst/>
+                      </a:pPr>
+                      <a:r>
+                        <a:rPr lang="en-US" sz="1200" b="0" i="0" u="none" strike="noStrike" cap="none" dirty="0">
+                          <a:solidFill>
+                            <a:schemeClr val="tx1"/>
+                          </a:solidFill>
+                          <a:latin typeface="+mn-lt"/>
+                          <a:ea typeface="+mn-ea"/>
+                          <a:cs typeface="+mn-cs"/>
+                          <a:sym typeface="Arial"/>
+                        </a:rPr>
+                        <a:t>Run MVP for collaboration platform</a:t>
+                      </a:r>
+                    </a:p>
+                    <a:p>
+                      <a:pPr marL="171450" marR="0" lvl="2" indent="-171450" algn="l" rtl="0">
+                        <a:lnSpc>
+                          <a:spcPct val="100000"/>
+                        </a:lnSpc>
+                        <a:spcBef>
+                          <a:spcPts val="0"/>
+                        </a:spcBef>
+                        <a:spcAft>
+                          <a:spcPts val="0"/>
+                        </a:spcAft>
+                        <a:buClr>
+                          <a:srgbClr val="000000"/>
+                        </a:buClr>
+                        <a:buFont typeface="Arial" panose="020B0604020202020204" pitchFamily="34" charset="0"/>
+                        <a:buChar char="•"/>
+                        <a:tabLst/>
+                      </a:pPr>
+                      <a:r>
+                        <a:rPr lang="en-US" sz="1200" b="0" i="0" u="none" strike="noStrike" cap="none" dirty="0">
+                          <a:solidFill>
+                            <a:schemeClr val="tx1"/>
+                          </a:solidFill>
+                          <a:latin typeface="+mn-lt"/>
+                          <a:ea typeface="+mn-ea"/>
+                          <a:cs typeface="+mn-cs"/>
+                          <a:sym typeface="Arial"/>
+                        </a:rPr>
+                        <a:t>Run MVPs for Freemium options</a:t>
+                      </a:r>
+                    </a:p>
+                  </a:txBody>
+                  <a:tcPr>
+                    <a:lnL w="12700" cmpd="sng">
+                      <a:noFill/>
+                    </a:lnL>
+                    <a:lnR w="12700" cap="flat" cmpd="sng" algn="ctr">
+                      <a:noFill/>
+                      <a:prstDash val="solid"/>
+                      <a:round/>
+                      <a:headEnd type="none" w="med" len="med"/>
+                      <a:tailEnd type="none" w="med" len="med"/>
+                    </a:lnR>
+                    <a:lnT w="12700" cap="flat" cmpd="sng" algn="ctr">
+                      <a:solidFill>
+                        <a:schemeClr val="tx1"/>
+                      </a:solidFill>
+                      <a:prstDash val="solid"/>
+                      <a:round/>
+                      <a:headEnd type="none" w="med" len="med"/>
+                      <a:tailEnd type="none" w="med" len="med"/>
+                    </a:lnT>
+                    <a:lnB w="12700" cap="flat" cmpd="sng" algn="ctr">
+                      <a:solidFill>
+                        <a:schemeClr val="tx1"/>
+                      </a:solidFill>
+                      <a:prstDash val="solid"/>
+                      <a:round/>
+                      <a:headEnd type="none" w="med" len="med"/>
+                      <a:tailEnd type="none" w="med" len="med"/>
+                    </a:lnB>
+                    <a:lnTlToBr w="12700" cmpd="sng">
+                      <a:noFill/>
+                      <a:prstDash val="solid"/>
+                    </a:lnTlToBr>
+                    <a:lnBlToTr w="12700" cmpd="sng">
+                      <a:noFill/>
+                      <a:prstDash val="solid"/>
+                    </a:lnBlToTr>
+                  </a:tcPr>
+                </a:tc>
+                <a:extLst>
+                  <a:ext uri="{0D108BD9-81ED-4DB2-BD59-A6C34878D82A}">
+                    <a16:rowId xmlns:a16="http://schemas.microsoft.com/office/drawing/2014/main" val="872717509"/>
+                  </a:ext>
+                </a:extLst>
+              </a:tr>
+              <a:tr h="1128631">
+                <a:tc>
+                  <a:txBody>
+                    <a:bodyPr/>
+                    <a:lstStyle/>
+                    <a:p>
+                      <a:r>
+                        <a:rPr lang="en-US" sz="2000" b="1" dirty="0"/>
+                        <a:t>Open Knowledge Sharing</a:t>
+                      </a:r>
+                    </a:p>
+                  </a:txBody>
+                  <a:tcPr>
+                    <a:lnL w="12700" cmpd="sng">
+                      <a:noFill/>
+                    </a:lnL>
+                    <a:lnR w="12700" cmpd="sng">
+                      <a:noFill/>
+                    </a:lnR>
+                    <a:lnT w="12700" cap="flat" cmpd="sng" algn="ctr">
+                      <a:solidFill>
+                        <a:schemeClr val="tx1"/>
+                      </a:solidFill>
+                      <a:prstDash val="solid"/>
+                      <a:round/>
+                      <a:headEnd type="none" w="med" len="med"/>
+                      <a:tailEnd type="none" w="med" len="med"/>
+                    </a:lnT>
+                    <a:lnB w="12700" cap="flat" cmpd="sng" algn="ctr">
+                      <a:solidFill>
+                        <a:schemeClr val="tx1"/>
+                      </a:solidFill>
+                      <a:prstDash val="solid"/>
+                      <a:round/>
+                      <a:headEnd type="none" w="med" len="med"/>
+                      <a:tailEnd type="none" w="med" len="med"/>
+                    </a:lnB>
+                    <a:lnTlToBr w="12700" cmpd="sng">
+                      <a:noFill/>
+                      <a:prstDash val="solid"/>
+                    </a:lnTlToBr>
+                    <a:lnBlToTr w="12700" cmpd="sng">
+                      <a:noFill/>
+                      <a:prstDash val="solid"/>
+                    </a:lnBlToTr>
+                  </a:tcPr>
+                </a:tc>
+                <a:tc>
+                  <a:txBody>
+                    <a:bodyPr/>
+                    <a:lstStyle/>
+                    <a:p>
+                      <a:pPr marL="171450" lvl="2" indent="-171450">
+                        <a:buFont typeface="Arial" panose="020B0604020202020204" pitchFamily="34" charset="0"/>
+                        <a:buChar char="•"/>
+                        <a:tabLst/>
+                      </a:pPr>
+                      <a:r>
+                        <a:rPr lang="en-US" sz="1200" b="0" i="0" u="none" strike="noStrike" cap="none" dirty="0">
+                          <a:solidFill>
+                            <a:schemeClr val="tx1"/>
+                          </a:solidFill>
+                          <a:effectLst/>
+                          <a:latin typeface="+mn-lt"/>
+                          <a:ea typeface="+mn-ea"/>
+                          <a:cs typeface="+mn-cs"/>
+                          <a:sym typeface="Arial"/>
+                        </a:rPr>
+                        <a:t>Learn from ASUG and PMI leaders how they developed and curate their BOKs</a:t>
+                      </a:r>
+                    </a:p>
+                    <a:p>
+                      <a:pPr marL="171450" lvl="2" indent="-171450">
+                        <a:buFont typeface="Arial" panose="020B0604020202020204" pitchFamily="34" charset="0"/>
+                        <a:buChar char="•"/>
+                        <a:tabLst/>
+                      </a:pPr>
+                      <a:r>
+                        <a:rPr lang="en-US" sz="1200" b="0" i="0" u="none" strike="noStrike" cap="none" dirty="0">
+                          <a:solidFill>
+                            <a:schemeClr val="tx1"/>
+                          </a:solidFill>
+                          <a:effectLst/>
+                          <a:latin typeface="+mn-lt"/>
+                          <a:ea typeface="+mn-ea"/>
+                          <a:cs typeface="+mn-cs"/>
+                          <a:sym typeface="Arial"/>
+                        </a:rPr>
+                        <a:t>Explore platforms for publishing and curating the AccelRR8 Framework and AccelRR8 Body of Knowledge (e.g., Github)</a:t>
+                      </a:r>
+                    </a:p>
+                    <a:p>
+                      <a:pPr marL="171450" lvl="2" indent="-171450">
+                        <a:buFont typeface="Arial" panose="020B0604020202020204" pitchFamily="34" charset="0"/>
+                        <a:buChar char="•"/>
+                        <a:tabLst/>
+                      </a:pPr>
+                      <a:r>
+                        <a:rPr lang="en-US" sz="1200" b="0" i="0" u="none" strike="noStrike" cap="none" dirty="0">
+                          <a:solidFill>
+                            <a:schemeClr val="tx1"/>
+                          </a:solidFill>
+                          <a:effectLst/>
+                          <a:latin typeface="+mn-lt"/>
+                          <a:ea typeface="+mn-ea"/>
+                          <a:cs typeface="+mn-cs"/>
+                          <a:sym typeface="Arial"/>
+                        </a:rPr>
+                        <a:t>Identify advisory board leaders for various topics</a:t>
+                      </a:r>
+                    </a:p>
+                    <a:p>
+                      <a:pPr marL="171450" lvl="2" indent="-171450">
+                        <a:buFont typeface="Arial" panose="020B0604020202020204" pitchFamily="34" charset="0"/>
+                        <a:buChar char="•"/>
+                        <a:tabLst/>
+                      </a:pPr>
+                      <a:r>
+                        <a:rPr lang="en-US" sz="1200" b="0" i="0" u="none" strike="noStrike" cap="none" dirty="0">
+                          <a:solidFill>
+                            <a:schemeClr val="tx1"/>
+                          </a:solidFill>
+                          <a:effectLst/>
+                          <a:latin typeface="+mn-lt"/>
+                          <a:ea typeface="+mn-ea"/>
+                          <a:cs typeface="+mn-cs"/>
+                          <a:sym typeface="Arial"/>
+                        </a:rPr>
+                        <a:t>Explore ways to enhance our credibility with Tech Services leaders, e.g., influencer endorsements and webinars</a:t>
+                      </a:r>
+                    </a:p>
+                    <a:p>
+                      <a:pPr marL="171450" lvl="2" indent="-171450">
+                        <a:buFont typeface="Arial" panose="020B0604020202020204" pitchFamily="34" charset="0"/>
+                        <a:buChar char="•"/>
+                        <a:tabLst/>
+                      </a:pPr>
+                      <a:r>
+                        <a:rPr lang="en-US" sz="1200" b="0" i="0" u="none" strike="noStrike" cap="none" dirty="0">
+                          <a:solidFill>
+                            <a:schemeClr val="tx1"/>
+                          </a:solidFill>
+                          <a:effectLst/>
+                          <a:latin typeface="+mn-lt"/>
+                          <a:ea typeface="+mn-ea"/>
+                          <a:cs typeface="+mn-cs"/>
+                          <a:sym typeface="Arial"/>
+                        </a:rPr>
+                        <a:t>Explore Freemium options for generating revenues (e.g., contributors)</a:t>
+                      </a:r>
+                      <a:endParaRPr lang="en-US" sz="1200" b="0" dirty="0">
+                        <a:solidFill>
+                          <a:schemeClr val="tx1"/>
+                        </a:solidFill>
+                      </a:endParaRPr>
+                    </a:p>
+                  </a:txBody>
+                  <a:tcPr>
+                    <a:lnL w="12700" cmpd="sng">
+                      <a:noFill/>
+                    </a:lnL>
+                    <a:lnR w="12700" cmpd="sng">
+                      <a:noFill/>
+                    </a:lnR>
+                    <a:lnT w="12700" cap="flat" cmpd="sng" algn="ctr">
+                      <a:solidFill>
+                        <a:schemeClr val="tx1"/>
+                      </a:solidFill>
+                      <a:prstDash val="solid"/>
+                      <a:round/>
+                      <a:headEnd type="none" w="med" len="med"/>
+                      <a:tailEnd type="none" w="med" len="med"/>
+                    </a:lnT>
+                    <a:lnB w="12700" cap="flat" cmpd="sng" algn="ctr">
+                      <a:solidFill>
+                        <a:schemeClr val="tx1"/>
+                      </a:solidFill>
+                      <a:prstDash val="solid"/>
+                      <a:round/>
+                      <a:headEnd type="none" w="med" len="med"/>
+                      <a:tailEnd type="none" w="med" len="med"/>
+                    </a:lnB>
+                    <a:lnTlToBr w="12700" cmpd="sng">
+                      <a:noFill/>
+                      <a:prstDash val="solid"/>
+                    </a:lnTlToBr>
+                    <a:lnBlToTr w="12700" cmpd="sng">
+                      <a:noFill/>
+                      <a:prstDash val="solid"/>
+                    </a:lnBlToTr>
+                  </a:tcPr>
+                </a:tc>
+                <a:tc>
+                  <a:txBody>
+                    <a:bodyPr/>
+                    <a:lstStyle/>
+                    <a:p>
+                      <a:pPr marL="171450" marR="0" lvl="2" indent="-171450" algn="l" rtl="0">
+                        <a:lnSpc>
+                          <a:spcPct val="100000"/>
+                        </a:lnSpc>
+                        <a:spcBef>
+                          <a:spcPts val="0"/>
+                        </a:spcBef>
+                        <a:spcAft>
+                          <a:spcPts val="0"/>
+                        </a:spcAft>
+                        <a:buClr>
+                          <a:srgbClr val="000000"/>
+                        </a:buClr>
+                        <a:buFont typeface="Arial" panose="020B0604020202020204" pitchFamily="34" charset="0"/>
+                        <a:buChar char="•"/>
+                        <a:tabLst/>
+                      </a:pPr>
+                      <a:r>
+                        <a:rPr lang="en-US" sz="1200" b="0" i="0" u="none" strike="noStrike" cap="none" dirty="0">
+                          <a:solidFill>
+                            <a:schemeClr val="tx1"/>
+                          </a:solidFill>
+                          <a:latin typeface="+mn-lt"/>
+                          <a:ea typeface="+mn-ea"/>
+                          <a:cs typeface="+mn-cs"/>
+                          <a:sym typeface="Arial"/>
+                        </a:rPr>
+                        <a:t>Identify Leader for Open Knowledge Sharing Service</a:t>
+                      </a:r>
+                    </a:p>
+                    <a:p>
+                      <a:pPr marL="171450" marR="0" lvl="2" indent="-171450" algn="l" rtl="0">
+                        <a:lnSpc>
+                          <a:spcPct val="100000"/>
+                        </a:lnSpc>
+                        <a:spcBef>
+                          <a:spcPts val="0"/>
+                        </a:spcBef>
+                        <a:spcAft>
+                          <a:spcPts val="0"/>
+                        </a:spcAft>
+                        <a:buClr>
+                          <a:srgbClr val="000000"/>
+                        </a:buClr>
+                        <a:buFont typeface="Arial" panose="020B0604020202020204" pitchFamily="34" charset="0"/>
+                        <a:buChar char="•"/>
+                        <a:tabLst/>
+                      </a:pPr>
+                      <a:r>
+                        <a:rPr lang="en-US" sz="1200" b="0" i="0" u="none" strike="noStrike" cap="none" dirty="0">
+                          <a:solidFill>
+                            <a:schemeClr val="tx1"/>
+                          </a:solidFill>
+                          <a:latin typeface="+mn-lt"/>
+                          <a:ea typeface="+mn-ea"/>
+                          <a:cs typeface="+mn-cs"/>
+                          <a:sym typeface="Arial"/>
+                        </a:rPr>
+                        <a:t>Publish the AccelRR8 Framework v2 on KM platform with help from Advisory board</a:t>
+                      </a:r>
+                    </a:p>
+                    <a:p>
+                      <a:pPr marL="171450" marR="0" lvl="2" indent="-171450" algn="l" rtl="0">
+                        <a:lnSpc>
+                          <a:spcPct val="100000"/>
+                        </a:lnSpc>
+                        <a:spcBef>
+                          <a:spcPts val="0"/>
+                        </a:spcBef>
+                        <a:spcAft>
+                          <a:spcPts val="0"/>
+                        </a:spcAft>
+                        <a:buClr>
+                          <a:srgbClr val="000000"/>
+                        </a:buClr>
+                        <a:buFont typeface="Arial" panose="020B0604020202020204" pitchFamily="34" charset="0"/>
+                        <a:buChar char="•"/>
+                        <a:tabLst/>
+                      </a:pPr>
+                      <a:r>
+                        <a:rPr lang="en-US" sz="1200" b="0" i="0" u="none" strike="noStrike" cap="none" dirty="0">
+                          <a:solidFill>
+                            <a:schemeClr val="tx1"/>
+                          </a:solidFill>
+                          <a:latin typeface="+mn-lt"/>
+                          <a:ea typeface="+mn-ea"/>
+                          <a:cs typeface="+mn-cs"/>
+                          <a:sym typeface="Arial"/>
+                        </a:rPr>
+                        <a:t>Run MVPs for webinars with influencers</a:t>
+                      </a:r>
+                    </a:p>
+                    <a:p>
+                      <a:pPr marL="171450" marR="0" lvl="2" indent="-171450" algn="l" rtl="0">
+                        <a:lnSpc>
+                          <a:spcPct val="100000"/>
+                        </a:lnSpc>
+                        <a:spcBef>
+                          <a:spcPts val="0"/>
+                        </a:spcBef>
+                        <a:spcAft>
+                          <a:spcPts val="0"/>
+                        </a:spcAft>
+                        <a:buClr>
+                          <a:srgbClr val="000000"/>
+                        </a:buClr>
+                        <a:buFont typeface="Arial" panose="020B0604020202020204" pitchFamily="34" charset="0"/>
+                        <a:buChar char="•"/>
+                        <a:tabLst/>
+                      </a:pPr>
+                      <a:r>
+                        <a:rPr lang="en-US" sz="1200" b="0" i="0" u="none" strike="noStrike" cap="none" dirty="0">
+                          <a:solidFill>
+                            <a:schemeClr val="tx1"/>
+                          </a:solidFill>
+                          <a:latin typeface="+mn-lt"/>
+                          <a:ea typeface="+mn-ea"/>
+                          <a:cs typeface="+mn-cs"/>
+                          <a:sym typeface="Arial"/>
+                        </a:rPr>
+                        <a:t>Run MVPs for Freemium options</a:t>
+                      </a:r>
+                    </a:p>
+                  </a:txBody>
+                  <a:tcPr>
+                    <a:lnL w="12700" cmpd="sng">
+                      <a:noFill/>
+                    </a:lnL>
+                    <a:lnR w="12700" cmpd="sng">
+                      <a:noFill/>
+                    </a:lnR>
+                    <a:lnT w="12700" cap="flat" cmpd="sng" algn="ctr">
+                      <a:solidFill>
+                        <a:schemeClr val="tx1"/>
+                      </a:solidFill>
+                      <a:prstDash val="solid"/>
+                      <a:round/>
+                      <a:headEnd type="none" w="med" len="med"/>
+                      <a:tailEnd type="none" w="med" len="med"/>
+                    </a:lnT>
+                    <a:lnB w="12700" cap="flat" cmpd="sng" algn="ctr">
+                      <a:solidFill>
+                        <a:schemeClr val="tx1"/>
+                      </a:solidFill>
+                      <a:prstDash val="solid"/>
+                      <a:round/>
+                      <a:headEnd type="none" w="med" len="med"/>
+                      <a:tailEnd type="none" w="med" len="med"/>
+                    </a:lnB>
+                    <a:lnTlToBr w="12700" cmpd="sng">
+                      <a:noFill/>
+                      <a:prstDash val="solid"/>
+                    </a:lnTlToBr>
+                    <a:lnBlToTr w="12700" cmpd="sng">
+                      <a:noFill/>
+                      <a:prstDash val="solid"/>
+                    </a:lnBlToTr>
+                  </a:tcPr>
+                </a:tc>
+                <a:extLst>
+                  <a:ext uri="{0D108BD9-81ED-4DB2-BD59-A6C34878D82A}">
+                    <a16:rowId xmlns:a16="http://schemas.microsoft.com/office/drawing/2014/main" val="3089640372"/>
+                  </a:ext>
+                </a:extLst>
+              </a:tr>
+              <a:tr h="1075015">
+                <a:tc>
+                  <a:txBody>
+                    <a:bodyPr/>
+                    <a:lstStyle/>
+                    <a:p>
+                      <a:r>
+                        <a:rPr lang="en-US" sz="2000" b="1" dirty="0"/>
+                        <a:t>Industry</a:t>
+                      </a:r>
+                    </a:p>
+                    <a:p>
+                      <a:r>
+                        <a:rPr lang="en-US" sz="2000" b="1" dirty="0"/>
+                        <a:t>Innovation</a:t>
+                      </a:r>
+                    </a:p>
+                  </a:txBody>
+                  <a:tcPr>
+                    <a:lnL w="12700" cmpd="sng">
+                      <a:noFill/>
+                    </a:lnL>
+                    <a:lnR w="12700" cmpd="sng">
+                      <a:noFill/>
+                    </a:lnR>
+                    <a:lnT w="12700" cap="flat" cmpd="sng" algn="ctr">
+                      <a:solidFill>
+                        <a:schemeClr val="tx1"/>
+                      </a:solidFill>
+                      <a:prstDash val="solid"/>
+                      <a:round/>
+                      <a:headEnd type="none" w="med" len="med"/>
+                      <a:tailEnd type="none" w="med" len="med"/>
+                    </a:lnT>
+                    <a:lnB w="12700" cap="flat" cmpd="sng" algn="ctr">
+                      <a:solidFill>
+                        <a:schemeClr val="tx1"/>
+                      </a:solidFill>
+                      <a:prstDash val="solid"/>
+                      <a:round/>
+                      <a:headEnd type="none" w="med" len="med"/>
+                      <a:tailEnd type="none" w="med" len="med"/>
+                    </a:lnB>
+                    <a:lnTlToBr w="12700" cmpd="sng">
+                      <a:noFill/>
+                      <a:prstDash val="solid"/>
+                    </a:lnTlToBr>
+                    <a:lnBlToTr w="12700" cmpd="sng">
+                      <a:noFill/>
+                      <a:prstDash val="solid"/>
+                    </a:lnBlToTr>
+                  </a:tcPr>
+                </a:tc>
+                <a:tc>
+                  <a:txBody>
+                    <a:bodyPr/>
+                    <a:lstStyle/>
+                    <a:p>
+                      <a:pPr marL="171450" lvl="2" indent="-171450">
+                        <a:buFont typeface="Arial" panose="020B0604020202020204" pitchFamily="34" charset="0"/>
+                        <a:buChar char="•"/>
+                        <a:tabLst/>
+                      </a:pPr>
+                      <a:r>
+                        <a:rPr lang="en-US" sz="1200" b="0" i="0" u="none" strike="noStrike" cap="none" dirty="0">
+                          <a:solidFill>
+                            <a:schemeClr val="tx1"/>
+                          </a:solidFill>
+                          <a:effectLst/>
+                          <a:latin typeface="+mn-lt"/>
+                          <a:ea typeface="+mn-ea"/>
+                          <a:cs typeface="+mn-cs"/>
+                          <a:sym typeface="Arial"/>
+                        </a:rPr>
+                        <a:t>Learn from ASUG and PMI leaders how they generate revenues from Patron organizations</a:t>
+                      </a:r>
+                    </a:p>
+                    <a:p>
+                      <a:pPr marL="171450" lvl="2" indent="-171450">
+                        <a:buFont typeface="Arial" panose="020B0604020202020204" pitchFamily="34" charset="0"/>
+                        <a:buChar char="•"/>
+                        <a:tabLst/>
+                      </a:pPr>
+                      <a:r>
+                        <a:rPr lang="en-US" sz="1200" b="0" i="0" u="none" strike="noStrike" cap="none" dirty="0">
+                          <a:solidFill>
+                            <a:schemeClr val="tx1"/>
+                          </a:solidFill>
+                          <a:effectLst/>
+                          <a:latin typeface="+mn-lt"/>
+                          <a:ea typeface="+mn-ea"/>
+                          <a:cs typeface="+mn-cs"/>
+                          <a:sym typeface="Arial"/>
+                        </a:rPr>
+                        <a:t>Explore opportunities to learn from and help initial Patron organizations</a:t>
+                      </a:r>
+                    </a:p>
+                    <a:p>
+                      <a:pPr marL="171450" lvl="2" indent="-171450">
+                        <a:buFont typeface="Arial" panose="020B0604020202020204" pitchFamily="34" charset="0"/>
+                        <a:buChar char="•"/>
+                        <a:tabLst/>
+                      </a:pPr>
+                      <a:r>
+                        <a:rPr lang="en-US" sz="1200" b="0" i="0" u="none" strike="noStrike" cap="none" dirty="0">
+                          <a:solidFill>
+                            <a:schemeClr val="tx1"/>
+                          </a:solidFill>
+                          <a:effectLst/>
+                          <a:latin typeface="+mn-lt"/>
+                          <a:ea typeface="+mn-ea"/>
+                          <a:cs typeface="+mn-cs"/>
+                          <a:sym typeface="Arial"/>
+                        </a:rPr>
+                        <a:t>Learn from AI for Good leaders how they use technology to help humanity</a:t>
+                      </a:r>
+                    </a:p>
+                    <a:p>
+                      <a:pPr marL="171450" lvl="2" indent="-171450">
+                        <a:buFont typeface="Arial" panose="020B0604020202020204" pitchFamily="34" charset="0"/>
+                        <a:buChar char="•"/>
+                        <a:tabLst/>
+                      </a:pPr>
+                      <a:r>
+                        <a:rPr lang="en-US" sz="1200" b="0" i="0" u="none" strike="noStrike" cap="none" dirty="0">
+                          <a:solidFill>
+                            <a:schemeClr val="tx1"/>
+                          </a:solidFill>
+                          <a:effectLst/>
+                          <a:latin typeface="+mn-lt"/>
+                          <a:ea typeface="+mn-ea"/>
+                          <a:cs typeface="+mn-cs"/>
+                          <a:sym typeface="Arial"/>
+                        </a:rPr>
+                        <a:t>Explore Freemium options for generating revenues (e.g., patron organizations)</a:t>
+                      </a:r>
+                      <a:endParaRPr lang="en-US" sz="1200" b="0" dirty="0">
+                        <a:solidFill>
+                          <a:srgbClr val="00B050"/>
+                        </a:solidFill>
+                      </a:endParaRPr>
+                    </a:p>
+                  </a:txBody>
+                  <a:tcPr>
+                    <a:lnL w="12700" cmpd="sng">
+                      <a:noFill/>
+                    </a:lnL>
+                    <a:lnR w="12700" cmpd="sng">
+                      <a:noFill/>
+                    </a:lnR>
+                    <a:lnT w="12700" cap="flat" cmpd="sng" algn="ctr">
+                      <a:solidFill>
+                        <a:schemeClr val="tx1"/>
+                      </a:solidFill>
+                      <a:prstDash val="solid"/>
+                      <a:round/>
+                      <a:headEnd type="none" w="med" len="med"/>
+                      <a:tailEnd type="none" w="med" len="med"/>
+                    </a:lnT>
+                    <a:lnB w="12700" cap="flat" cmpd="sng" algn="ctr">
+                      <a:solidFill>
+                        <a:schemeClr val="tx1"/>
+                      </a:solidFill>
+                      <a:prstDash val="solid"/>
+                      <a:round/>
+                      <a:headEnd type="none" w="med" len="med"/>
+                      <a:tailEnd type="none" w="med" len="med"/>
+                    </a:lnB>
+                    <a:lnTlToBr w="12700" cmpd="sng">
+                      <a:noFill/>
+                      <a:prstDash val="solid"/>
+                    </a:lnTlToBr>
+                    <a:lnBlToTr w="12700" cmpd="sng">
+                      <a:noFill/>
+                      <a:prstDash val="solid"/>
+                    </a:lnBlToTr>
+                  </a:tcPr>
+                </a:tc>
+                <a:tc>
+                  <a:txBody>
+                    <a:bodyPr/>
+                    <a:lstStyle/>
+                    <a:p>
+                      <a:pPr marL="171450" marR="0" lvl="2" indent="-171450" algn="l" rtl="0">
+                        <a:lnSpc>
+                          <a:spcPct val="100000"/>
+                        </a:lnSpc>
+                        <a:spcBef>
+                          <a:spcPts val="0"/>
+                        </a:spcBef>
+                        <a:spcAft>
+                          <a:spcPts val="0"/>
+                        </a:spcAft>
+                        <a:buClr>
+                          <a:srgbClr val="000000"/>
+                        </a:buClr>
+                        <a:buFont typeface="Arial" panose="020B0604020202020204" pitchFamily="34" charset="0"/>
+                        <a:buChar char="•"/>
+                        <a:tabLst/>
+                      </a:pPr>
+                      <a:r>
+                        <a:rPr lang="en-US" sz="1200" b="0" i="0" u="none" strike="noStrike" cap="none" dirty="0">
+                          <a:solidFill>
+                            <a:schemeClr val="tx1"/>
+                          </a:solidFill>
+                          <a:latin typeface="+mn-lt"/>
+                          <a:ea typeface="+mn-ea"/>
+                          <a:cs typeface="+mn-cs"/>
+                          <a:sym typeface="Arial"/>
+                        </a:rPr>
+                        <a:t>Identify Leader for Industry Innovation Service</a:t>
+                      </a:r>
+                    </a:p>
+                    <a:p>
+                      <a:pPr marL="171450" marR="0" lvl="2" indent="-171450" algn="l" rtl="0">
+                        <a:lnSpc>
+                          <a:spcPct val="100000"/>
+                        </a:lnSpc>
+                        <a:spcBef>
+                          <a:spcPts val="0"/>
+                        </a:spcBef>
+                        <a:spcAft>
+                          <a:spcPts val="0"/>
+                        </a:spcAft>
+                        <a:buClr>
+                          <a:srgbClr val="000000"/>
+                        </a:buClr>
+                        <a:buFont typeface="Arial" panose="020B0604020202020204" pitchFamily="34" charset="0"/>
+                        <a:buChar char="•"/>
+                        <a:tabLst/>
+                      </a:pPr>
+                      <a:r>
+                        <a:rPr lang="en-US" sz="1200" b="0" i="0" u="none" strike="noStrike" cap="none" dirty="0">
+                          <a:solidFill>
+                            <a:schemeClr val="tx1"/>
+                          </a:solidFill>
+                          <a:latin typeface="+mn-lt"/>
+                          <a:ea typeface="+mn-ea"/>
+                          <a:cs typeface="+mn-cs"/>
+                          <a:sym typeface="Arial"/>
+                        </a:rPr>
+                        <a:t>Run MVPs for Freemium options</a:t>
+                      </a:r>
+                    </a:p>
+                  </a:txBody>
+                  <a:tcPr>
+                    <a:lnL w="12700" cmpd="sng">
+                      <a:noFill/>
+                    </a:lnL>
+                    <a:lnR w="12700" cmpd="sng">
+                      <a:noFill/>
+                    </a:lnR>
+                    <a:lnT w="12700" cap="flat" cmpd="sng" algn="ctr">
+                      <a:solidFill>
+                        <a:schemeClr val="tx1"/>
+                      </a:solidFill>
+                      <a:prstDash val="solid"/>
+                      <a:round/>
+                      <a:headEnd type="none" w="med" len="med"/>
+                      <a:tailEnd type="none" w="med" len="med"/>
+                    </a:lnT>
+                    <a:lnB w="12700" cap="flat" cmpd="sng" algn="ctr">
+                      <a:solidFill>
+                        <a:schemeClr val="tx1"/>
+                      </a:solidFill>
+                      <a:prstDash val="solid"/>
+                      <a:round/>
+                      <a:headEnd type="none" w="med" len="med"/>
+                      <a:tailEnd type="none" w="med" len="med"/>
+                    </a:lnB>
+                    <a:lnTlToBr w="12700" cmpd="sng">
+                      <a:noFill/>
+                      <a:prstDash val="solid"/>
+                    </a:lnTlToBr>
+                    <a:lnBlToTr w="12700" cmpd="sng">
+                      <a:noFill/>
+                      <a:prstDash val="solid"/>
+                    </a:lnBlToTr>
+                  </a:tcPr>
+                </a:tc>
+                <a:extLst>
+                  <a:ext uri="{0D108BD9-81ED-4DB2-BD59-A6C34878D82A}">
+                    <a16:rowId xmlns:a16="http://schemas.microsoft.com/office/drawing/2014/main" val="2047728929"/>
+                  </a:ext>
+                </a:extLst>
+              </a:tr>
+              <a:tr h="1075015">
+                <a:tc>
+                  <a:txBody>
+                    <a:bodyPr/>
+                    <a:lstStyle/>
+                    <a:p>
+                      <a:r>
+                        <a:rPr lang="en-US" sz="2000" b="1" dirty="0"/>
+                        <a:t>Services Platform</a:t>
+                      </a:r>
+                    </a:p>
+                  </a:txBody>
+                  <a:tcPr>
+                    <a:lnL w="12700" cmpd="sng">
+                      <a:noFill/>
+                    </a:lnL>
+                    <a:lnR w="12700" cmpd="sng">
+                      <a:noFill/>
+                    </a:lnR>
+                    <a:lnT w="12700" cap="flat" cmpd="sng" algn="ctr">
+                      <a:solidFill>
+                        <a:schemeClr val="tx1"/>
+                      </a:solidFill>
+                      <a:prstDash val="solid"/>
+                      <a:round/>
+                      <a:headEnd type="none" w="med" len="med"/>
+                      <a:tailEnd type="none" w="med" len="med"/>
+                    </a:lnT>
+                    <a:lnB w="12700" cap="flat" cmpd="sng" algn="ctr">
+                      <a:solidFill>
+                        <a:schemeClr val="tx1"/>
+                      </a:solidFill>
+                      <a:prstDash val="solid"/>
+                      <a:round/>
+                      <a:headEnd type="none" w="med" len="med"/>
+                      <a:tailEnd type="none" w="med" len="med"/>
+                    </a:lnB>
+                    <a:lnTlToBr w="12700" cmpd="sng">
+                      <a:noFill/>
+                      <a:prstDash val="solid"/>
+                    </a:lnTlToBr>
+                    <a:lnBlToTr w="12700" cmpd="sng">
+                      <a:noFill/>
+                      <a:prstDash val="solid"/>
+                    </a:lnBlToTr>
+                  </a:tcPr>
+                </a:tc>
+                <a:tc>
+                  <a:txBody>
+                    <a:bodyPr/>
+                    <a:lstStyle/>
+                    <a:p>
+                      <a:pPr marL="171450" lvl="2" indent="-171450">
+                        <a:buFont typeface="Arial" panose="020B0604020202020204" pitchFamily="34" charset="0"/>
+                        <a:buChar char="•"/>
+                        <a:tabLst/>
+                      </a:pPr>
+                      <a:r>
+                        <a:rPr lang="en-US" sz="1200" b="0" dirty="0">
+                          <a:solidFill>
+                            <a:schemeClr val="tx1"/>
+                          </a:solidFill>
+                        </a:rPr>
+                        <a:t>Use Lean Product Management to publish Services info on our LinkedIn page</a:t>
+                      </a:r>
+                    </a:p>
+                    <a:p>
+                      <a:pPr marL="171450" lvl="2" indent="-171450">
+                        <a:buFont typeface="Arial" panose="020B0604020202020204" pitchFamily="34" charset="0"/>
+                        <a:buChar char="•"/>
+                        <a:tabLst/>
+                      </a:pPr>
+                      <a:r>
+                        <a:rPr lang="en-US" sz="1200" b="0" dirty="0">
+                          <a:solidFill>
+                            <a:schemeClr val="tx1"/>
+                          </a:solidFill>
+                        </a:rPr>
+                        <a:t>Explore low-cost options for setting up a website (e.g., Wordpress)</a:t>
+                      </a:r>
+                    </a:p>
+                    <a:p>
+                      <a:pPr marL="171450" lvl="2" indent="-171450">
+                        <a:buFont typeface="Arial" panose="020B0604020202020204" pitchFamily="34" charset="0"/>
+                        <a:buChar char="•"/>
+                        <a:tabLst/>
+                      </a:pPr>
+                      <a:r>
+                        <a:rPr lang="en-US" sz="1200" b="0" dirty="0">
+                          <a:solidFill>
+                            <a:schemeClr val="tx1"/>
+                          </a:solidFill>
+                        </a:rPr>
+                        <a:t>Experiment with and practice using AI to help our Consortium scale</a:t>
+                      </a:r>
+                    </a:p>
+                    <a:p>
+                      <a:pPr marL="171450" lvl="2" indent="-171450">
+                        <a:buFont typeface="Arial" panose="020B0604020202020204" pitchFamily="34" charset="0"/>
+                        <a:buChar char="•"/>
+                        <a:tabLst/>
+                      </a:pPr>
+                      <a:r>
+                        <a:rPr lang="en-US" sz="1200" b="0" dirty="0">
+                          <a:solidFill>
+                            <a:schemeClr val="tx1"/>
+                          </a:solidFill>
+                        </a:rPr>
+                        <a:t>Explore ideas for raising seed money (donations and grants)</a:t>
+                      </a:r>
+                    </a:p>
+                  </a:txBody>
+                  <a:tcPr>
+                    <a:lnL w="12700" cmpd="sng">
+                      <a:noFill/>
+                    </a:lnL>
+                    <a:lnR w="12700" cmpd="sng">
+                      <a:noFill/>
+                    </a:lnR>
+                    <a:lnT w="12700" cap="flat" cmpd="sng" algn="ctr">
+                      <a:solidFill>
+                        <a:schemeClr val="tx1"/>
+                      </a:solidFill>
+                      <a:prstDash val="solid"/>
+                      <a:round/>
+                      <a:headEnd type="none" w="med" len="med"/>
+                      <a:tailEnd type="none" w="med" len="med"/>
+                    </a:lnT>
+                    <a:lnB w="12700" cap="flat" cmpd="sng" algn="ctr">
+                      <a:solidFill>
+                        <a:schemeClr val="tx1"/>
+                      </a:solidFill>
+                      <a:prstDash val="solid"/>
+                      <a:round/>
+                      <a:headEnd type="none" w="med" len="med"/>
+                      <a:tailEnd type="none" w="med" len="med"/>
+                    </a:lnB>
+                    <a:lnTlToBr w="12700" cmpd="sng">
+                      <a:noFill/>
+                      <a:prstDash val="solid"/>
+                    </a:lnTlToBr>
+                    <a:lnBlToTr w="12700" cmpd="sng">
+                      <a:noFill/>
+                      <a:prstDash val="solid"/>
+                    </a:lnBlToTr>
+                  </a:tcPr>
+                </a:tc>
+                <a:tc>
+                  <a:txBody>
+                    <a:bodyPr/>
+                    <a:lstStyle/>
+                    <a:p>
+                      <a:pPr marL="171450" marR="0" lvl="2" indent="-171450" algn="l" rtl="0">
+                        <a:lnSpc>
+                          <a:spcPct val="100000"/>
+                        </a:lnSpc>
+                        <a:spcBef>
+                          <a:spcPts val="0"/>
+                        </a:spcBef>
+                        <a:spcAft>
+                          <a:spcPts val="0"/>
+                        </a:spcAft>
+                        <a:buClr>
+                          <a:srgbClr val="000000"/>
+                        </a:buClr>
+                        <a:buFont typeface="Arial" panose="020B0604020202020204" pitchFamily="34" charset="0"/>
+                        <a:buChar char="•"/>
+                        <a:tabLst/>
+                      </a:pPr>
+                      <a:r>
+                        <a:rPr lang="en-US" sz="1200" b="0" i="0" u="none" strike="noStrike" cap="none" dirty="0">
+                          <a:solidFill>
+                            <a:schemeClr val="tx1"/>
+                          </a:solidFill>
                           <a:latin typeface="+mn-lt"/>
                           <a:ea typeface="+mn-ea"/>
                           <a:cs typeface="+mn-cs"/>
@@ -19679,8 +21158,8 @@
                         <a:buClr>
                           <a:srgbClr val="000000"/>
                         </a:buClr>
-                        <a:buFont typeface="Wingdings" pitchFamily="2" charset="2"/>
-                        <a:buChar char="q"/>
+                        <a:buFont typeface="Arial" panose="020B0604020202020204" pitchFamily="34" charset="0"/>
+                        <a:buChar char="•"/>
                         <a:tabLst/>
                       </a:pPr>
                       <a:r>
@@ -19688,9 +21167,6 @@
                           <a:solidFill>
                             <a:schemeClr val="tx1"/>
                           </a:solidFill>
-                          <a:highlight>
-                            <a:srgbClr val="FFFF00"/>
-                          </a:highlight>
                           <a:latin typeface="+mn-lt"/>
                           <a:ea typeface="+mn-ea"/>
                           <a:cs typeface="+mn-cs"/>
@@ -19704,12 +21180,8 @@
                     <a:lnL w="12700" cmpd="sng">
                       <a:noFill/>
                     </a:lnL>
-                    <a:lnR w="12700" cap="flat" cmpd="sng" algn="ctr">
-                      <a:noFill/>
-                      <a:prstDash val="solid"/>
-                      <a:round/>
-                      <a:headEnd type="none" w="med" len="med"/>
-                      <a:tailEnd type="none" w="med" len="med"/>
+                    <a:lnR w="12700" cmpd="sng">
+                      <a:noFill/>
                     </a:lnR>
                     <a:lnT w="12700" cap="flat" cmpd="sng" algn="ctr">
                       <a:solidFill>
@@ -19741,7 +21213,290 @@
                 </a:tc>
                 <a:extLst>
                   <a:ext uri="{0D108BD9-81ED-4DB2-BD59-A6C34878D82A}">
-                    <a16:rowId xmlns:a16="http://schemas.microsoft.com/office/drawing/2014/main" val="901597007"/>
+                    <a16:rowId xmlns:a16="http://schemas.microsoft.com/office/drawing/2014/main" val="3822362779"/>
+                  </a:ext>
+                </a:extLst>
+              </a:tr>
+            </a:tbl>
+          </a:graphicData>
+        </a:graphic>
+      </p:graphicFrame>
+    </p:spTree>
+    <p:extLst>
+      <p:ext uri="{BB962C8B-B14F-4D97-AF65-F5344CB8AC3E}">
+        <p14:creationId xmlns:p14="http://schemas.microsoft.com/office/powerpoint/2010/main" val="2470097404"/>
+      </p:ext>
+    </p:extLst>
+  </p:cSld>
+  <p:clrMapOvr>
+    <a:masterClrMapping/>
+  </p:clrMapOvr>
+</p:sld>
+</file>
+
+<file path=ppt/slides/slide7.xml><?xml version="1.0" encoding="utf-8"?>
+<p:sld xmlns:a="http://schemas.openxmlformats.org/drawingml/2006/main" xmlns:r="http://schemas.openxmlformats.org/officeDocument/2006/relationships" xmlns:p="http://schemas.openxmlformats.org/presentationml/2006/main">
+  <p:cSld>
+    <p:spTree>
+      <p:nvGrpSpPr>
+        <p:cNvPr id="1" name="Shape 95">
+          <a:extLst>
+            <a:ext uri="{FF2B5EF4-FFF2-40B4-BE49-F238E27FC236}">
+              <a16:creationId xmlns:a16="http://schemas.microsoft.com/office/drawing/2014/main" id="{9CF0030E-C778-6057-7F00-D64497814302}"/>
+            </a:ext>
+          </a:extLst>
+        </p:cNvPr>
+        <p:cNvGrpSpPr/>
+        <p:nvPr/>
+      </p:nvGrpSpPr>
+      <p:grpSpPr>
+        <a:xfrm>
+          <a:off x="0" y="0"/>
+          <a:ext cx="0" cy="0"/>
+          <a:chOff x="0" y="0"/>
+          <a:chExt cx="0" cy="0"/>
+        </a:xfrm>
+      </p:grpSpPr>
+      <p:sp>
+        <p:nvSpPr>
+          <p:cNvPr id="96" name="Google Shape;96;p2">
+            <a:extLst>
+              <a:ext uri="{FF2B5EF4-FFF2-40B4-BE49-F238E27FC236}">
+                <a16:creationId xmlns:a16="http://schemas.microsoft.com/office/drawing/2014/main" id="{213A3A61-4044-D39A-7839-F3AEFE0C296B}"/>
+              </a:ext>
+            </a:extLst>
+          </p:cNvPr>
+          <p:cNvSpPr txBox="1">
+            <a:spLocks noGrp="1"/>
+          </p:cNvSpPr>
+          <p:nvPr>
+            <p:ph type="title"/>
+          </p:nvPr>
+        </p:nvSpPr>
+        <p:spPr>
+          <a:prstGeom prst="rect">
+            <a:avLst/>
+          </a:prstGeom>
+          <a:noFill/>
+          <a:ln>
+            <a:noFill/>
+          </a:ln>
+        </p:spPr>
+        <p:txBody>
+          <a:bodyPr spcFirstLastPara="1" wrap="square" lIns="91425" tIns="45700" rIns="91425" bIns="45700" anchor="ctr" anchorCtr="0">
+            <a:normAutofit/>
+          </a:bodyPr>
+          <a:lstStyle/>
+          <a:p>
+            <a:pPr marL="0" lvl="0" indent="0" algn="l" rtl="0">
+              <a:lnSpc>
+                <a:spcPct val="90000"/>
+              </a:lnSpc>
+              <a:spcBef>
+                <a:spcPts val="0"/>
+              </a:spcBef>
+              <a:spcAft>
+                <a:spcPts val="0"/>
+              </a:spcAft>
+              <a:buClr>
+                <a:schemeClr val="dk1"/>
+              </a:buClr>
+              <a:buSzPts val="4400"/>
+              <a:buFont typeface="Calibri"/>
+              <a:buNone/>
+            </a:pPr>
+            <a:r>
+              <a:rPr lang="en-US" dirty="0"/>
+              <a:t>Roadmap to Launch (Horizon 1)</a:t>
+            </a:r>
+            <a:br>
+              <a:rPr lang="en-US" dirty="0"/>
+            </a:br>
+            <a:r>
+              <a:rPr lang="en-US" dirty="0"/>
+              <a:t>Status</a:t>
+            </a:r>
+            <a:endParaRPr dirty="0"/>
+          </a:p>
+        </p:txBody>
+      </p:sp>
+      <p:graphicFrame>
+        <p:nvGraphicFramePr>
+          <p:cNvPr id="5" name="Table 4">
+            <a:extLst>
+              <a:ext uri="{FF2B5EF4-FFF2-40B4-BE49-F238E27FC236}">
+                <a16:creationId xmlns:a16="http://schemas.microsoft.com/office/drawing/2014/main" id="{5855B0BF-5869-4C17-DDB9-4330FF90D640}"/>
+              </a:ext>
+            </a:extLst>
+          </p:cNvPr>
+          <p:cNvGraphicFramePr>
+            <a:graphicFrameLocks noGrp="1"/>
+          </p:cNvGraphicFramePr>
+          <p:nvPr>
+            <p:extLst>
+              <p:ext uri="{D42A27DB-BD31-4B8C-83A1-F6EECF244321}">
+                <p14:modId xmlns:p14="http://schemas.microsoft.com/office/powerpoint/2010/main" val="1979126813"/>
+              </p:ext>
+            </p:extLst>
+          </p:nvPr>
+        </p:nvGraphicFramePr>
+        <p:xfrm>
+          <a:off x="410934" y="1560399"/>
+          <a:ext cx="11370132" cy="5025887"/>
+        </p:xfrm>
+        <a:graphic>
+          <a:graphicData uri="http://schemas.openxmlformats.org/drawingml/2006/table">
+            <a:tbl>
+              <a:tblPr firstRow="1" bandRow="1">
+                <a:tableStyleId>{5940675A-B579-460E-94D1-54222C63F5DA}</a:tableStyleId>
+              </a:tblPr>
+              <a:tblGrid>
+                <a:gridCol w="2079172">
+                  <a:extLst>
+                    <a:ext uri="{9D8B030D-6E8A-4147-A177-3AD203B41FA5}">
+                      <a16:colId xmlns:a16="http://schemas.microsoft.com/office/drawing/2014/main" val="533583650"/>
+                    </a:ext>
+                  </a:extLst>
+                </a:gridCol>
+                <a:gridCol w="5856515">
+                  <a:extLst>
+                    <a:ext uri="{9D8B030D-6E8A-4147-A177-3AD203B41FA5}">
+                      <a16:colId xmlns:a16="http://schemas.microsoft.com/office/drawing/2014/main" val="766325045"/>
+                    </a:ext>
+                  </a:extLst>
+                </a:gridCol>
+                <a:gridCol w="3434445">
+                  <a:extLst>
+                    <a:ext uri="{9D8B030D-6E8A-4147-A177-3AD203B41FA5}">
+                      <a16:colId xmlns:a16="http://schemas.microsoft.com/office/drawing/2014/main" val="133755"/>
+                    </a:ext>
+                  </a:extLst>
+                </a:gridCol>
+              </a:tblGrid>
+              <a:tr h="315537">
+                <a:tc>
+                  <a:txBody>
+                    <a:bodyPr/>
+                    <a:lstStyle/>
+                    <a:p>
+                      <a:r>
+                        <a:rPr lang="en-US" sz="1400" b="1" dirty="0"/>
+                        <a:t>Service</a:t>
+                      </a:r>
+                    </a:p>
+                  </a:txBody>
+                  <a:tcPr>
+                    <a:lnL w="12700" cmpd="sng">
+                      <a:noFill/>
+                    </a:lnL>
+                    <a:lnR w="12700" cmpd="sng">
+                      <a:noFill/>
+                    </a:lnR>
+                    <a:lnT w="12700" cmpd="sng">
+                      <a:noFill/>
+                    </a:lnT>
+                    <a:lnB w="12700" cap="flat" cmpd="sng" algn="ctr">
+                      <a:solidFill>
+                        <a:schemeClr val="tx1"/>
+                      </a:solidFill>
+                      <a:prstDash val="solid"/>
+                      <a:round/>
+                      <a:headEnd type="none" w="med" len="med"/>
+                      <a:tailEnd type="none" w="med" len="med"/>
+                    </a:lnB>
+                    <a:lnTlToBr w="12700" cmpd="sng">
+                      <a:noFill/>
+                      <a:prstDash val="solid"/>
+                    </a:lnTlToBr>
+                    <a:lnBlToTr w="12700" cmpd="sng">
+                      <a:noFill/>
+                      <a:prstDash val="solid"/>
+                    </a:lnBlToTr>
+                  </a:tcPr>
+                </a:tc>
+                <a:tc>
+                  <a:txBody>
+                    <a:bodyPr/>
+                    <a:lstStyle/>
+                    <a:p>
+                      <a:r>
+                        <a:rPr lang="en-US" b="1" dirty="0"/>
+                        <a:t>Soon</a:t>
+                      </a:r>
+                    </a:p>
+                  </a:txBody>
+                  <a:tcPr>
+                    <a:lnL w="12700" cmpd="sng">
+                      <a:noFill/>
+                    </a:lnL>
+                    <a:lnR w="12700" cmpd="sng">
+                      <a:noFill/>
+                    </a:lnR>
+                    <a:lnT w="12700" cmpd="sng">
+                      <a:noFill/>
+                    </a:lnT>
+                    <a:lnB w="12700" cap="flat" cmpd="sng" algn="ctr">
+                      <a:solidFill>
+                        <a:schemeClr val="tx1"/>
+                      </a:solidFill>
+                      <a:prstDash val="solid"/>
+                      <a:round/>
+                      <a:headEnd type="none" w="med" len="med"/>
+                      <a:tailEnd type="none" w="med" len="med"/>
+                    </a:lnB>
+                    <a:lnTlToBr w="12700" cmpd="sng">
+                      <a:noFill/>
+                      <a:prstDash val="solid"/>
+                    </a:lnTlToBr>
+                    <a:lnBlToTr w="12700" cmpd="sng">
+                      <a:noFill/>
+                      <a:prstDash val="solid"/>
+                    </a:lnBlToTr>
+                  </a:tcPr>
+                </a:tc>
+                <a:tc>
+                  <a:txBody>
+                    <a:bodyPr/>
+                    <a:lstStyle/>
+                    <a:p>
+                      <a:r>
+                        <a:rPr lang="en-US" b="1" dirty="0"/>
+                        <a:t>When Feasible</a:t>
+                      </a:r>
+                    </a:p>
+                  </a:txBody>
+                  <a:tcPr>
+                    <a:lnL w="12700" cmpd="sng">
+                      <a:noFill/>
+                    </a:lnL>
+                    <a:lnR w="12700" cmpd="sng">
+                      <a:noFill/>
+                    </a:lnR>
+                    <a:lnT w="12700" cmpd="sng">
+                      <a:noFill/>
+                    </a:lnT>
+                    <a:lnB w="12700" cap="flat" cmpd="sng" algn="ctr">
+                      <a:solidFill>
+                        <a:schemeClr val="tx1"/>
+                      </a:solidFill>
+                      <a:prstDash val="solid"/>
+                      <a:round/>
+                      <a:headEnd type="none" w="med" len="med"/>
+                      <a:tailEnd type="none" w="med" len="med"/>
+                    </a:lnB>
+                    <a:lnTlToBr w="12700" cmpd="sng">
+                      <a:noFill/>
+                      <a:prstDash val="solid"/>
+                    </a:lnTlToBr>
+                    <a:lnBlToTr w="12700" cmpd="sng">
+                      <a:noFill/>
+                      <a:prstDash val="solid"/>
+                    </a:lnBlToTr>
+                  </a:tcPr>
+                </a:tc>
+                <a:extLst>
+                  <a:ext uri="{0D108BD9-81ED-4DB2-BD59-A6C34878D82A}">
+                    <a16:rowId xmlns:a16="http://schemas.microsoft.com/office/drawing/2014/main" val="1454970526"/>
                   </a:ext>
                 </a:extLst>
               </a:tr>
@@ -19812,9 +21567,6 @@
                             <a:schemeClr val="tx1"/>
                           </a:solidFill>
                           <a:effectLst/>
-                          <a:highlight>
-                            <a:srgbClr val="FFFF00"/>
-                          </a:highlight>
                           <a:latin typeface="+mn-lt"/>
                           <a:ea typeface="+mn-ea"/>
                           <a:cs typeface="+mn-cs"/>
@@ -19840,7 +21592,7 @@
                           <a:cs typeface="+mn-cs"/>
                           <a:sym typeface="Arial"/>
                         </a:rPr>
-                        <a:t>Grow the number of Collaborators to 100 via the Board of Directors</a:t>
+                        <a:t>Grow the number of Subscribers to 100 via the Board of Directors</a:t>
                       </a:r>
                     </a:p>
                     <a:p>
@@ -19855,9 +21607,6 @@
                             <a:schemeClr val="tx1"/>
                           </a:solidFill>
                           <a:effectLst/>
-                          <a:highlight>
-                            <a:srgbClr val="FFFF00"/>
-                          </a:highlight>
                           <a:latin typeface="+mn-lt"/>
                           <a:ea typeface="+mn-ea"/>
                           <a:cs typeface="+mn-cs"/>
@@ -19883,7 +21632,7 @@
                           <a:cs typeface="+mn-cs"/>
                           <a:sym typeface="Arial"/>
                         </a:rPr>
-                        <a:t>Prepare a campaign to grow the number of Collaborators to 300</a:t>
+                        <a:t>Prepare a campaign to grow the number of Subscribers to 300</a:t>
                       </a:r>
                     </a:p>
                     <a:p>
@@ -20014,7 +21763,7 @@
                           <a:cs typeface="+mn-cs"/>
                           <a:sym typeface="Arial"/>
                         </a:rPr>
-                        <a:t>Run campaigns to grow the number of Collaborators to 300 and then to 1,000</a:t>
+                        <a:t>Run campaigns to grow the number of Subscribers to 300 and then to 1,000</a:t>
                       </a:r>
                     </a:p>
                     <a:p>
@@ -20188,9 +21937,6 @@
                             <a:schemeClr val="tx1"/>
                           </a:solidFill>
                           <a:effectLst/>
-                          <a:highlight>
-                            <a:srgbClr val="FFFF00"/>
-                          </a:highlight>
                           <a:latin typeface="+mn-lt"/>
                           <a:ea typeface="+mn-ea"/>
                           <a:cs typeface="+mn-cs"/>
@@ -20211,9 +21957,6 @@
                             <a:schemeClr val="tx1"/>
                           </a:solidFill>
                           <a:effectLst/>
-                          <a:highlight>
-                            <a:srgbClr val="FFFF00"/>
-                          </a:highlight>
                           <a:latin typeface="+mn-lt"/>
                           <a:ea typeface="+mn-ea"/>
                           <a:cs typeface="+mn-cs"/>
@@ -20254,9 +21997,6 @@
                             <a:schemeClr val="tx1"/>
                           </a:solidFill>
                           <a:effectLst/>
-                          <a:highlight>
-                            <a:srgbClr val="FFFF00"/>
-                          </a:highlight>
                           <a:latin typeface="+mn-lt"/>
                           <a:ea typeface="+mn-ea"/>
                           <a:cs typeface="+mn-cs"/>
@@ -20376,7 +22116,7 @@
                           <a:srgbClr val="000000"/>
                         </a:buClr>
                         <a:buFont typeface="Wingdings" pitchFamily="2" charset="2"/>
-                        <a:buChar char="q"/>
+                        <a:buChar char="ü"/>
                         <a:tabLst/>
                       </a:pPr>
                       <a:r>
@@ -20565,15 +22305,12 @@
                             <a:schemeClr val="tx1"/>
                           </a:solidFill>
                           <a:effectLst/>
-                          <a:highlight>
-                            <a:srgbClr val="FFFF00"/>
-                          </a:highlight>
                           <a:latin typeface="+mn-lt"/>
                           <a:ea typeface="+mn-ea"/>
                           <a:cs typeface="+mn-cs"/>
                           <a:sym typeface="Arial"/>
                         </a:rPr>
-                        <a:t>Learn from ASUG and PMI leaders how they generate revenues from patron organizations</a:t>
+                        <a:t>Learn from ASUG and PMI leaders how they generate revenues from Patron organizations</a:t>
                       </a:r>
                     </a:p>
                     <a:p>
@@ -20588,15 +22325,12 @@
                             <a:schemeClr val="tx1"/>
                           </a:solidFill>
                           <a:effectLst/>
-                          <a:highlight>
-                            <a:srgbClr val="FFFF00"/>
-                          </a:highlight>
                           <a:latin typeface="+mn-lt"/>
                           <a:ea typeface="+mn-ea"/>
                           <a:cs typeface="+mn-cs"/>
                           <a:sym typeface="Arial"/>
                         </a:rPr>
-                        <a:t>Explore opportunities to learn from and help the Bender Leadership Academy</a:t>
+                        <a:t>Explore opportunities to learn from and help initial Patron organizations</a:t>
                       </a:r>
                     </a:p>
                     <a:p>
@@ -20611,9 +22345,6 @@
                             <a:schemeClr val="tx1"/>
                           </a:solidFill>
                           <a:effectLst/>
-                          <a:highlight>
-                            <a:srgbClr val="FFFF00"/>
-                          </a:highlight>
                           <a:latin typeface="+mn-lt"/>
                           <a:ea typeface="+mn-ea"/>
                           <a:cs typeface="+mn-cs"/>
@@ -20791,81 +22522,265 @@
                   </a:ext>
                 </a:extLst>
               </a:tr>
+              <a:tr h="1075015">
+                <a:tc>
+                  <a:txBody>
+                    <a:bodyPr/>
+                    <a:lstStyle/>
+                    <a:p>
+                      <a:r>
+                        <a:rPr lang="en-US" sz="2000" b="1" dirty="0"/>
+                        <a:t>Services Platform</a:t>
+                      </a:r>
+                    </a:p>
+                  </a:txBody>
+                  <a:tcPr>
+                    <a:lnL w="12700" cmpd="sng">
+                      <a:noFill/>
+                    </a:lnL>
+                    <a:lnR w="12700" cmpd="sng">
+                      <a:noFill/>
+                    </a:lnR>
+                    <a:lnT w="12700" cap="flat" cmpd="sng" algn="ctr">
+                      <a:solidFill>
+                        <a:schemeClr val="tx1"/>
+                      </a:solidFill>
+                      <a:prstDash val="solid"/>
+                      <a:round/>
+                      <a:headEnd type="none" w="med" len="med"/>
+                      <a:tailEnd type="none" w="med" len="med"/>
+                    </a:lnT>
+                    <a:lnB w="12700" cap="flat" cmpd="sng" algn="ctr">
+                      <a:solidFill>
+                        <a:schemeClr val="tx1"/>
+                      </a:solidFill>
+                      <a:prstDash val="solid"/>
+                      <a:round/>
+                      <a:headEnd type="none" w="med" len="med"/>
+                      <a:tailEnd type="none" w="med" len="med"/>
+                    </a:lnB>
+                    <a:lnTlToBr w="12700" cmpd="sng">
+                      <a:noFill/>
+                      <a:prstDash val="solid"/>
+                    </a:lnTlToBr>
+                    <a:lnBlToTr w="12700" cmpd="sng">
+                      <a:noFill/>
+                      <a:prstDash val="solid"/>
+                    </a:lnBlToTr>
+                  </a:tcPr>
+                </a:tc>
+                <a:tc>
+                  <a:txBody>
+                    <a:bodyPr/>
+                    <a:lstStyle/>
+                    <a:p>
+                      <a:pPr marL="171450" lvl="2" indent="-171450">
+                        <a:buFont typeface="Wingdings" pitchFamily="2" charset="2"/>
+                        <a:buChar char="ü"/>
+                        <a:tabLst/>
+                      </a:pPr>
+                      <a:r>
+                        <a:rPr lang="en-US" sz="1200" b="0" dirty="0">
+                          <a:solidFill>
+                            <a:schemeClr val="tx1"/>
+                          </a:solidFill>
+                        </a:rPr>
+                        <a:t>Use Lean Product Management to publish Services info on our LinkedIn page</a:t>
+                      </a:r>
+                    </a:p>
+                    <a:p>
+                      <a:pPr marL="171450" lvl="2" indent="-171450">
+                        <a:buFont typeface="Wingdings" pitchFamily="2" charset="2"/>
+                        <a:buChar char="ü"/>
+                        <a:tabLst/>
+                      </a:pPr>
+                      <a:r>
+                        <a:rPr lang="en-US" sz="1200" b="0" dirty="0">
+                          <a:solidFill>
+                            <a:schemeClr val="tx1"/>
+                          </a:solidFill>
+                        </a:rPr>
+                        <a:t>Explore low-cost options for setting up a website (e.g., Wordpress)</a:t>
+                      </a:r>
+                    </a:p>
+                    <a:p>
+                      <a:pPr marL="171450" lvl="2" indent="-171450">
+                        <a:buFont typeface="Wingdings" pitchFamily="2" charset="2"/>
+                        <a:buChar char="q"/>
+                        <a:tabLst/>
+                      </a:pPr>
+                      <a:r>
+                        <a:rPr lang="en-US" sz="1200" b="0" dirty="0">
+                          <a:solidFill>
+                            <a:schemeClr val="tx1"/>
+                          </a:solidFill>
+                        </a:rPr>
+                        <a:t>Experiment with and practice using AI to help our Consortium scale</a:t>
+                      </a:r>
+                    </a:p>
+                    <a:p>
+                      <a:pPr marL="171450" lvl="2" indent="-171450">
+                        <a:buFont typeface="Wingdings" pitchFamily="2" charset="2"/>
+                        <a:buChar char="q"/>
+                        <a:tabLst/>
+                      </a:pPr>
+                      <a:r>
+                        <a:rPr lang="en-US" sz="1200" b="0" dirty="0">
+                          <a:solidFill>
+                            <a:schemeClr val="tx1"/>
+                          </a:solidFill>
+                        </a:rPr>
+                        <a:t>Explore ideas for raising seed money (donations and grants)</a:t>
+                      </a:r>
+                    </a:p>
+                  </a:txBody>
+                  <a:tcPr>
+                    <a:lnL w="12700" cmpd="sng">
+                      <a:noFill/>
+                    </a:lnL>
+                    <a:lnR w="12700" cmpd="sng">
+                      <a:noFill/>
+                    </a:lnR>
+                    <a:lnT w="12700" cap="flat" cmpd="sng" algn="ctr">
+                      <a:solidFill>
+                        <a:schemeClr val="tx1"/>
+                      </a:solidFill>
+                      <a:prstDash val="solid"/>
+                      <a:round/>
+                      <a:headEnd type="none" w="med" len="med"/>
+                      <a:tailEnd type="none" w="med" len="med"/>
+                    </a:lnT>
+                    <a:lnB w="12700" cap="flat" cmpd="sng" algn="ctr">
+                      <a:solidFill>
+                        <a:schemeClr val="tx1"/>
+                      </a:solidFill>
+                      <a:prstDash val="solid"/>
+                      <a:round/>
+                      <a:headEnd type="none" w="med" len="med"/>
+                      <a:tailEnd type="none" w="med" len="med"/>
+                    </a:lnB>
+                    <a:lnTlToBr w="12700" cmpd="sng">
+                      <a:noFill/>
+                      <a:prstDash val="solid"/>
+                    </a:lnTlToBr>
+                    <a:lnBlToTr w="12700" cmpd="sng">
+                      <a:noFill/>
+                      <a:prstDash val="solid"/>
+                    </a:lnBlToTr>
+                  </a:tcPr>
+                </a:tc>
+                <a:tc>
+                  <a:txBody>
+                    <a:bodyPr/>
+                    <a:lstStyle/>
+                    <a:p>
+                      <a:pPr marL="171450" marR="0" lvl="2" indent="-171450" algn="l" rtl="0">
+                        <a:lnSpc>
+                          <a:spcPct val="100000"/>
+                        </a:lnSpc>
+                        <a:spcBef>
+                          <a:spcPts val="0"/>
+                        </a:spcBef>
+                        <a:spcAft>
+                          <a:spcPts val="0"/>
+                        </a:spcAft>
+                        <a:buClr>
+                          <a:srgbClr val="000000"/>
+                        </a:buClr>
+                        <a:buFont typeface="Wingdings" pitchFamily="2" charset="2"/>
+                        <a:buChar char="ü"/>
+                        <a:tabLst/>
+                      </a:pPr>
+                      <a:r>
+                        <a:rPr lang="en-US" sz="1200" b="0" i="0" u="none" strike="noStrike" cap="none" dirty="0">
+                          <a:solidFill>
+                            <a:schemeClr val="tx1"/>
+                          </a:solidFill>
+                          <a:latin typeface="+mn-lt"/>
+                          <a:ea typeface="+mn-ea"/>
+                          <a:cs typeface="+mn-cs"/>
+                          <a:sym typeface="Arial"/>
+                        </a:rPr>
+                        <a:t>Set up a website</a:t>
+                      </a:r>
+                    </a:p>
+                    <a:p>
+                      <a:pPr marL="171450" marR="0" lvl="2" indent="-171450" algn="l" rtl="0">
+                        <a:lnSpc>
+                          <a:spcPct val="100000"/>
+                        </a:lnSpc>
+                        <a:spcBef>
+                          <a:spcPts val="0"/>
+                        </a:spcBef>
+                        <a:spcAft>
+                          <a:spcPts val="0"/>
+                        </a:spcAft>
+                        <a:buClr>
+                          <a:srgbClr val="000000"/>
+                        </a:buClr>
+                        <a:buFont typeface="Wingdings" pitchFamily="2" charset="2"/>
+                        <a:buChar char="q"/>
+                        <a:tabLst/>
+                      </a:pPr>
+                      <a:r>
+                        <a:rPr lang="en-US" sz="1200" b="0" i="0" u="none" strike="noStrike" cap="none" dirty="0">
+                          <a:solidFill>
+                            <a:schemeClr val="tx1"/>
+                          </a:solidFill>
+                          <a:latin typeface="+mn-lt"/>
+                          <a:ea typeface="+mn-ea"/>
+                          <a:cs typeface="+mn-cs"/>
+                          <a:sym typeface="Arial"/>
+                        </a:rPr>
+                        <a:t>Publish learnings (e.g., how we’re using AI) in the AccelRR8 Body of Knowledge</a:t>
+                      </a:r>
+                    </a:p>
+                  </a:txBody>
+                  <a:tcPr>
+                    <a:lnL w="12700" cmpd="sng">
+                      <a:noFill/>
+                    </a:lnL>
+                    <a:lnR w="12700" cmpd="sng">
+                      <a:noFill/>
+                    </a:lnR>
+                    <a:lnT w="12700" cap="flat" cmpd="sng" algn="ctr">
+                      <a:solidFill>
+                        <a:schemeClr val="tx1"/>
+                      </a:solidFill>
+                      <a:prstDash val="solid"/>
+                      <a:round/>
+                      <a:headEnd type="none" w="med" len="med"/>
+                      <a:tailEnd type="none" w="med" len="med"/>
+                    </a:lnT>
+                    <a:lnB w="12700" cap="flat" cmpd="sng" algn="ctr">
+                      <a:solidFill>
+                        <a:schemeClr val="tx1"/>
+                      </a:solidFill>
+                      <a:prstDash val="solid"/>
+                      <a:round/>
+                      <a:headEnd type="none" w="med" len="med"/>
+                      <a:tailEnd type="none" w="med" len="med"/>
+                    </a:lnB>
+                    <a:lnTlToBr w="12700" cmpd="sng">
+                      <a:noFill/>
+                      <a:prstDash val="solid"/>
+                    </a:lnTlToBr>
+                    <a:lnBlToTr w="12700" cmpd="sng">
+                      <a:noFill/>
+                      <a:prstDash val="solid"/>
+                    </a:lnBlToTr>
+                  </a:tcPr>
+                </a:tc>
+                <a:extLst>
+                  <a:ext uri="{0D108BD9-81ED-4DB2-BD59-A6C34878D82A}">
+                    <a16:rowId xmlns:a16="http://schemas.microsoft.com/office/drawing/2014/main" val="3822362779"/>
+                  </a:ext>
+                </a:extLst>
+              </a:tr>
             </a:tbl>
           </a:graphicData>
         </a:graphic>
       </p:graphicFrame>
-      <p:sp>
-        <p:nvSpPr>
-          <p:cNvPr id="8" name="TextBox 7">
-            <a:extLst>
-              <a:ext uri="{FF2B5EF4-FFF2-40B4-BE49-F238E27FC236}">
-                <a16:creationId xmlns:a16="http://schemas.microsoft.com/office/drawing/2014/main" id="{98161617-7B83-FBD0-E788-6EDFBDE6F761}"/>
-              </a:ext>
-            </a:extLst>
-          </p:cNvPr>
-          <p:cNvSpPr txBox="1"/>
-          <p:nvPr/>
-        </p:nvSpPr>
-        <p:spPr>
-          <a:xfrm>
-            <a:off x="935019" y="211236"/>
-            <a:ext cx="4443805" cy="307777"/>
-          </a:xfrm>
-          <a:prstGeom prst="rect">
-            <a:avLst/>
-          </a:prstGeom>
-          <a:solidFill>
-            <a:schemeClr val="bg1"/>
-          </a:solidFill>
-        </p:spPr>
-        <p:txBody>
-          <a:bodyPr wrap="square">
-            <a:spAutoFit/>
-          </a:bodyPr>
-          <a:lstStyle/>
-          <a:p>
-            <a:pPr marR="0" lvl="0" algn="l" defTabSz="914400" rtl="0" eaLnBrk="1" fontAlgn="auto" latinLnBrk="0" hangingPunct="1">
-              <a:lnSpc>
-                <a:spcPct val="100000"/>
-              </a:lnSpc>
-              <a:spcBef>
-                <a:spcPts val="0"/>
-              </a:spcBef>
-              <a:spcAft>
-                <a:spcPts val="0"/>
-              </a:spcAft>
-              <a:buClr>
-                <a:srgbClr val="000000"/>
-              </a:buClr>
-              <a:buSzTx/>
-              <a:tabLst/>
-              <a:defRPr/>
-            </a:pPr>
-            <a:r>
-              <a:rPr kumimoji="0" lang="en-US" sz="1400" i="0" u="none" strike="noStrike" kern="1200" cap="none" spc="0" normalizeH="0" baseline="0" noProof="0" dirty="0">
-                <a:ln>
-                  <a:noFill/>
-                </a:ln>
-                <a:solidFill>
-                  <a:schemeClr val="tx1"/>
-                </a:solidFill>
-                <a:effectLst/>
-                <a:highlight>
-                  <a:srgbClr val="FFFF00"/>
-                </a:highlight>
-                <a:uLnTx/>
-                <a:uFillTx/>
-                <a:latin typeface="Aptos" panose="02110004020202020204"/>
-                <a:ea typeface="+mn-ea"/>
-                <a:cs typeface="Arial"/>
-                <a:sym typeface="Arial"/>
-              </a:rPr>
-              <a:t>Actions aligned to the priorities are highlighted in yellow</a:t>
-            </a:r>
-          </a:p>
-        </p:txBody>
-      </p:sp>
     </p:spTree>
     <p:extLst>
       <p:ext uri="{BB962C8B-B14F-4D97-AF65-F5344CB8AC3E}">
@@ -20879,7 +22794,7 @@
 </p:sld>
 </file>
 
-<file path=ppt/slides/slide7.xml><?xml version="1.0" encoding="utf-8"?>
+<file path=ppt/slides/slide8.xml><?xml version="1.0" encoding="utf-8"?>
 <p:sld xmlns:a="http://schemas.openxmlformats.org/drawingml/2006/main" xmlns:r="http://schemas.openxmlformats.org/officeDocument/2006/relationships" xmlns:p="http://schemas.openxmlformats.org/presentationml/2006/main">
   <p:cSld>
     <p:spTree>
@@ -21869,7 +23784,7 @@
 </p:sld>
 </file>
 
-<file path=ppt/slides/slide8.xml><?xml version="1.0" encoding="utf-8"?>
+<file path=ppt/slides/slide9.xml><?xml version="1.0" encoding="utf-8"?>
 <p:sld xmlns:a="http://schemas.openxmlformats.org/drawingml/2006/main" xmlns:r="http://schemas.openxmlformats.org/officeDocument/2006/relationships" xmlns:p="http://schemas.openxmlformats.org/presentationml/2006/main">
   <p:cSld>
     <p:spTree>
@@ -21918,174 +23833,6 @@
     <p:extLst>
       <p:ext uri="{BB962C8B-B14F-4D97-AF65-F5344CB8AC3E}">
         <p14:creationId xmlns:p14="http://schemas.microsoft.com/office/powerpoint/2010/main" val="463985386"/>
-      </p:ext>
-    </p:extLst>
-  </p:cSld>
-  <p:clrMapOvr>
-    <a:masterClrMapping/>
-  </p:clrMapOvr>
-</p:sld>
-</file>
-
-<file path=ppt/slides/slide9.xml><?xml version="1.0" encoding="utf-8"?>
-<p:sld xmlns:a="http://schemas.openxmlformats.org/drawingml/2006/main" xmlns:r="http://schemas.openxmlformats.org/officeDocument/2006/relationships" xmlns:p="http://schemas.openxmlformats.org/presentationml/2006/main">
-  <p:cSld>
-    <p:spTree>
-      <p:nvGrpSpPr>
-        <p:cNvPr id="1" name="Shape 120">
-          <a:extLst>
-            <a:ext uri="{FF2B5EF4-FFF2-40B4-BE49-F238E27FC236}">
-              <a16:creationId xmlns:a16="http://schemas.microsoft.com/office/drawing/2014/main" id="{ECDE25D5-7ABB-9ADA-350B-500231E65541}"/>
-            </a:ext>
-          </a:extLst>
-        </p:cNvPr>
-        <p:cNvGrpSpPr/>
-        <p:nvPr/>
-      </p:nvGrpSpPr>
-      <p:grpSpPr>
-        <a:xfrm>
-          <a:off x="0" y="0"/>
-          <a:ext cx="0" cy="0"/>
-          <a:chOff x="0" y="0"/>
-          <a:chExt cx="0" cy="0"/>
-        </a:xfrm>
-      </p:grpSpPr>
-      <p:sp>
-        <p:nvSpPr>
-          <p:cNvPr id="121" name="Google Shape;121;p5">
-            <a:extLst>
-              <a:ext uri="{FF2B5EF4-FFF2-40B4-BE49-F238E27FC236}">
-                <a16:creationId xmlns:a16="http://schemas.microsoft.com/office/drawing/2014/main" id="{D1FD5753-66B3-EA4B-4895-9891C1AB6723}"/>
-              </a:ext>
-            </a:extLst>
-          </p:cNvPr>
-          <p:cNvSpPr txBox="1">
-            <a:spLocks noGrp="1"/>
-          </p:cNvSpPr>
-          <p:nvPr>
-            <p:ph type="title"/>
-          </p:nvPr>
-        </p:nvSpPr>
-        <p:spPr>
-          <a:xfrm>
-            <a:off x="838199" y="365125"/>
-            <a:ext cx="8950569" cy="1325563"/>
-          </a:xfrm>
-          <a:prstGeom prst="rect">
-            <a:avLst/>
-          </a:prstGeom>
-          <a:noFill/>
-          <a:ln>
-            <a:noFill/>
-          </a:ln>
-        </p:spPr>
-        <p:txBody>
-          <a:bodyPr spcFirstLastPara="1" wrap="square" lIns="91425" tIns="45700" rIns="91425" bIns="45700" anchor="ctr" anchorCtr="0">
-            <a:normAutofit/>
-          </a:bodyPr>
-          <a:lstStyle/>
-          <a:p>
-            <a:pPr marL="0" lvl="0" indent="0" algn="l" rtl="0">
-              <a:lnSpc>
-                <a:spcPct val="90000"/>
-              </a:lnSpc>
-              <a:spcBef>
-                <a:spcPts val="0"/>
-              </a:spcBef>
-              <a:spcAft>
-                <a:spcPts val="0"/>
-              </a:spcAft>
-              <a:buClr>
-                <a:schemeClr val="dk1"/>
-              </a:buClr>
-              <a:buSzPts val="4400"/>
-              <a:buFont typeface="Calibri"/>
-              <a:buNone/>
-            </a:pPr>
-            <a:r>
-              <a:rPr lang="en-US" dirty="0"/>
-              <a:t>Portfolio Kanban Reference</a:t>
-            </a:r>
-            <a:endParaRPr dirty="0"/>
-          </a:p>
-        </p:txBody>
-      </p:sp>
-      <p:pic>
-        <p:nvPicPr>
-          <p:cNvPr id="32" name="Picture 31">
-            <a:extLst>
-              <a:ext uri="{FF2B5EF4-FFF2-40B4-BE49-F238E27FC236}">
-                <a16:creationId xmlns:a16="http://schemas.microsoft.com/office/drawing/2014/main" id="{D3616900-0C58-1E90-22AE-07E41FA90C5C}"/>
-              </a:ext>
-            </a:extLst>
-          </p:cNvPr>
-          <p:cNvPicPr>
-            <a:picLocks noChangeAspect="1"/>
-          </p:cNvPicPr>
-          <p:nvPr/>
-        </p:nvPicPr>
-        <p:blipFill>
-          <a:blip r:embed="rId3"/>
-          <a:stretch>
-            <a:fillRect/>
-          </a:stretch>
-        </p:blipFill>
-        <p:spPr>
-          <a:xfrm>
-            <a:off x="116361" y="1609391"/>
-            <a:ext cx="11959278" cy="4748877"/>
-          </a:xfrm>
-          <a:prstGeom prst="rect">
-            <a:avLst/>
-          </a:prstGeom>
-        </p:spPr>
-      </p:pic>
-      <p:sp>
-        <p:nvSpPr>
-          <p:cNvPr id="2" name="TextBox 1">
-            <a:extLst>
-              <a:ext uri="{FF2B5EF4-FFF2-40B4-BE49-F238E27FC236}">
-                <a16:creationId xmlns:a16="http://schemas.microsoft.com/office/drawing/2014/main" id="{FA549193-7BF6-72BD-7395-1DB5F0173929}"/>
-              </a:ext>
-            </a:extLst>
-          </p:cNvPr>
-          <p:cNvSpPr txBox="1"/>
-          <p:nvPr/>
-        </p:nvSpPr>
-        <p:spPr>
-          <a:xfrm>
-            <a:off x="385763" y="6050491"/>
-            <a:ext cx="5867312" cy="307777"/>
-          </a:xfrm>
-          <a:prstGeom prst="rect">
-            <a:avLst/>
-          </a:prstGeom>
-          <a:noFill/>
-        </p:spPr>
-        <p:txBody>
-          <a:bodyPr wrap="none" rtlCol="0">
-            <a:spAutoFit/>
-          </a:bodyPr>
-          <a:lstStyle/>
-          <a:p>
-            <a:r>
-              <a:rPr lang="en-US" dirty="0"/>
-              <a:t>To learn more, visit the </a:t>
-            </a:r>
-            <a:r>
-              <a:rPr lang="en-US" dirty="0">
-                <a:hlinkClick r:id="rId4"/>
-              </a:rPr>
-              <a:t>Scaled Agile Framework Portfolio Backlog article</a:t>
-            </a:r>
-            <a:endParaRPr lang="en-US" dirty="0"/>
-          </a:p>
-        </p:txBody>
-      </p:sp>
-    </p:spTree>
-    <p:extLst>
-      <p:ext uri="{BB962C8B-B14F-4D97-AF65-F5344CB8AC3E}">
-        <p14:creationId xmlns:p14="http://schemas.microsoft.com/office/powerpoint/2010/main" val="3601186110"/>
       </p:ext>
     </p:extLst>
   </p:cSld>

</xml_diff>